<commit_message>
Correct author names in report and presentation
Patil Sakshi and Manpreet Kaur in the report author block and
on the presentation title slide.
</commit_message>
<xml_diff>
--- a/presentation/SectionC_Team17_presentation.pptx
+++ b/presentation/SectionC_Team17_presentation.pptx
@@ -72,13 +72,13 @@
         </a:solidFill>
         <a:effectLst/>
         <a:uFillTx/>
-        <a:latin typeface="+mj-lt"/>
-        <a:ea typeface="+mj-ea"/>
-        <a:cs typeface="+mj-cs"/>
-        <a:sym typeface="Calibri"/>
+        <a:latin typeface="+mn-lt"/>
+        <a:ea typeface="+mn-ea"/>
+        <a:cs typeface="+mn-cs"/>
+        <a:sym typeface="Helvetica"/>
       </a:defRPr>
     </a:lvl1pPr>
-    <a:lvl2pPr marL="0" marR="0" indent="457200" algn="l" defTabSz="914400" rtl="0" fontAlgn="auto" latinLnBrk="0" hangingPunct="0">
+    <a:lvl2pPr marL="0" marR="0" indent="0" algn="l" defTabSz="914400" rtl="0" fontAlgn="auto" latinLnBrk="0" hangingPunct="0">
       <a:lnSpc>
         <a:spcPct val="100000"/>
       </a:lnSpc>
@@ -102,13 +102,13 @@
         </a:solidFill>
         <a:effectLst/>
         <a:uFillTx/>
-        <a:latin typeface="+mj-lt"/>
-        <a:ea typeface="+mj-ea"/>
-        <a:cs typeface="+mj-cs"/>
-        <a:sym typeface="Calibri"/>
+        <a:latin typeface="+mn-lt"/>
+        <a:ea typeface="+mn-ea"/>
+        <a:cs typeface="+mn-cs"/>
+        <a:sym typeface="Helvetica"/>
       </a:defRPr>
     </a:lvl2pPr>
-    <a:lvl3pPr marL="0" marR="0" indent="914400" algn="l" defTabSz="914400" rtl="0" fontAlgn="auto" latinLnBrk="0" hangingPunct="0">
+    <a:lvl3pPr marL="0" marR="0" indent="0" algn="l" defTabSz="914400" rtl="0" fontAlgn="auto" latinLnBrk="0" hangingPunct="0">
       <a:lnSpc>
         <a:spcPct val="100000"/>
       </a:lnSpc>
@@ -132,13 +132,13 @@
         </a:solidFill>
         <a:effectLst/>
         <a:uFillTx/>
-        <a:latin typeface="+mj-lt"/>
-        <a:ea typeface="+mj-ea"/>
-        <a:cs typeface="+mj-cs"/>
-        <a:sym typeface="Calibri"/>
+        <a:latin typeface="+mn-lt"/>
+        <a:ea typeface="+mn-ea"/>
+        <a:cs typeface="+mn-cs"/>
+        <a:sym typeface="Helvetica"/>
       </a:defRPr>
     </a:lvl3pPr>
-    <a:lvl4pPr marL="0" marR="0" indent="1371600" algn="l" defTabSz="914400" rtl="0" fontAlgn="auto" latinLnBrk="0" hangingPunct="0">
+    <a:lvl4pPr marL="0" marR="0" indent="0" algn="l" defTabSz="914400" rtl="0" fontAlgn="auto" latinLnBrk="0" hangingPunct="0">
       <a:lnSpc>
         <a:spcPct val="100000"/>
       </a:lnSpc>
@@ -162,13 +162,13 @@
         </a:solidFill>
         <a:effectLst/>
         <a:uFillTx/>
-        <a:latin typeface="+mj-lt"/>
-        <a:ea typeface="+mj-ea"/>
-        <a:cs typeface="+mj-cs"/>
-        <a:sym typeface="Calibri"/>
+        <a:latin typeface="+mn-lt"/>
+        <a:ea typeface="+mn-ea"/>
+        <a:cs typeface="+mn-cs"/>
+        <a:sym typeface="Helvetica"/>
       </a:defRPr>
     </a:lvl4pPr>
-    <a:lvl5pPr marL="0" marR="0" indent="1828800" algn="l" defTabSz="914400" rtl="0" fontAlgn="auto" latinLnBrk="0" hangingPunct="0">
+    <a:lvl5pPr marL="0" marR="0" indent="0" algn="l" defTabSz="914400" rtl="0" fontAlgn="auto" latinLnBrk="0" hangingPunct="0">
       <a:lnSpc>
         <a:spcPct val="100000"/>
       </a:lnSpc>
@@ -192,13 +192,13 @@
         </a:solidFill>
         <a:effectLst/>
         <a:uFillTx/>
-        <a:latin typeface="+mj-lt"/>
-        <a:ea typeface="+mj-ea"/>
-        <a:cs typeface="+mj-cs"/>
-        <a:sym typeface="Calibri"/>
+        <a:latin typeface="+mn-lt"/>
+        <a:ea typeface="+mn-ea"/>
+        <a:cs typeface="+mn-cs"/>
+        <a:sym typeface="Helvetica"/>
       </a:defRPr>
     </a:lvl5pPr>
-    <a:lvl6pPr marL="0" marR="0" indent="2286000" algn="l" defTabSz="914400" rtl="0" fontAlgn="auto" latinLnBrk="0" hangingPunct="0">
+    <a:lvl6pPr marL="0" marR="0" indent="0" algn="l" defTabSz="914400" rtl="0" fontAlgn="auto" latinLnBrk="0" hangingPunct="0">
       <a:lnSpc>
         <a:spcPct val="100000"/>
       </a:lnSpc>
@@ -222,13 +222,13 @@
         </a:solidFill>
         <a:effectLst/>
         <a:uFillTx/>
-        <a:latin typeface="+mj-lt"/>
-        <a:ea typeface="+mj-ea"/>
-        <a:cs typeface="+mj-cs"/>
-        <a:sym typeface="Calibri"/>
+        <a:latin typeface="+mn-lt"/>
+        <a:ea typeface="+mn-ea"/>
+        <a:cs typeface="+mn-cs"/>
+        <a:sym typeface="Helvetica"/>
       </a:defRPr>
     </a:lvl6pPr>
-    <a:lvl7pPr marL="0" marR="0" indent="2743200" algn="l" defTabSz="914400" rtl="0" fontAlgn="auto" latinLnBrk="0" hangingPunct="0">
+    <a:lvl7pPr marL="0" marR="0" indent="0" algn="l" defTabSz="914400" rtl="0" fontAlgn="auto" latinLnBrk="0" hangingPunct="0">
       <a:lnSpc>
         <a:spcPct val="100000"/>
       </a:lnSpc>
@@ -252,13 +252,13 @@
         </a:solidFill>
         <a:effectLst/>
         <a:uFillTx/>
-        <a:latin typeface="+mj-lt"/>
-        <a:ea typeface="+mj-ea"/>
-        <a:cs typeface="+mj-cs"/>
-        <a:sym typeface="Calibri"/>
+        <a:latin typeface="+mn-lt"/>
+        <a:ea typeface="+mn-ea"/>
+        <a:cs typeface="+mn-cs"/>
+        <a:sym typeface="Helvetica"/>
       </a:defRPr>
     </a:lvl7pPr>
-    <a:lvl8pPr marL="0" marR="0" indent="3200400" algn="l" defTabSz="914400" rtl="0" fontAlgn="auto" latinLnBrk="0" hangingPunct="0">
+    <a:lvl8pPr marL="0" marR="0" indent="0" algn="l" defTabSz="914400" rtl="0" fontAlgn="auto" latinLnBrk="0" hangingPunct="0">
       <a:lnSpc>
         <a:spcPct val="100000"/>
       </a:lnSpc>
@@ -282,13 +282,13 @@
         </a:solidFill>
         <a:effectLst/>
         <a:uFillTx/>
-        <a:latin typeface="+mj-lt"/>
-        <a:ea typeface="+mj-ea"/>
-        <a:cs typeface="+mj-cs"/>
-        <a:sym typeface="Calibri"/>
+        <a:latin typeface="+mn-lt"/>
+        <a:ea typeface="+mn-ea"/>
+        <a:cs typeface="+mn-cs"/>
+        <a:sym typeface="Helvetica"/>
       </a:defRPr>
     </a:lvl8pPr>
-    <a:lvl9pPr marL="0" marR="0" indent="3657600" algn="l" defTabSz="914400" rtl="0" fontAlgn="auto" latinLnBrk="0" hangingPunct="0">
+    <a:lvl9pPr marL="0" marR="0" indent="0" algn="l" defTabSz="914400" rtl="0" fontAlgn="auto" latinLnBrk="0" hangingPunct="0">
       <a:lnSpc>
         <a:spcPct val="100000"/>
       </a:lnSpc>
@@ -312,10 +312,10 @@
         </a:solidFill>
         <a:effectLst/>
         <a:uFillTx/>
-        <a:latin typeface="+mj-lt"/>
-        <a:ea typeface="+mj-ea"/>
-        <a:cs typeface="+mj-cs"/>
-        <a:sym typeface="Calibri"/>
+        <a:latin typeface="+mn-lt"/>
+        <a:ea typeface="+mn-ea"/>
+        <a:cs typeface="+mn-cs"/>
+        <a:sym typeface="Helvetica"/>
       </a:defRPr>
     </a:lvl9pPr>
   </p:defaultTextStyle>
@@ -1255,8 +1255,8 @@
         </p:nvSpPr>
         <p:spPr>
           <a:xfrm>
-            <a:off x="609600" y="92074"/>
-            <a:ext cx="10972800" cy="1508127"/>
+            <a:off x="1826683" y="769937"/>
+            <a:ext cx="9753601" cy="1668463"/>
           </a:xfrm>
           <a:prstGeom prst="rect">
             <a:avLst/>
@@ -1271,7 +1271,7 @@
           </a:extLst>
         </p:spPr>
         <p:txBody>
-          <a:bodyPr lIns="45719" rIns="45719" anchor="ctr"/>
+          <a:bodyPr lIns="45718" tIns="45718" rIns="45718" bIns="45718" anchor="ctr"/>
           <a:lstStyle/>
           <a:p>
             <a:pPr/>
@@ -1291,8 +1291,8 @@
         </p:nvSpPr>
         <p:spPr>
           <a:xfrm>
-            <a:off x="609600" y="1600200"/>
-            <a:ext cx="10972800" cy="5257800"/>
+            <a:off x="6805083" y="2438400"/>
+            <a:ext cx="4775201" cy="4419600"/>
           </a:xfrm>
           <a:prstGeom prst="rect">
             <a:avLst/>
@@ -1307,7 +1307,7 @@
           </a:extLst>
         </p:spPr>
         <p:txBody>
-          <a:bodyPr lIns="45719" rIns="45719"/>
+          <a:bodyPr lIns="45718" tIns="45718" rIns="45718" bIns="45718"/>
           <a:lstStyle/>
           <a:p>
             <a:pPr/>
@@ -1351,8 +1351,8 @@
         </p:nvSpPr>
         <p:spPr>
           <a:xfrm>
-            <a:off x="5892800" y="6172200"/>
-            <a:ext cx="2844800" cy="368301"/>
+            <a:off x="8478978" y="6232199"/>
+            <a:ext cx="258623" cy="248303"/>
           </a:xfrm>
           <a:prstGeom prst="rect">
             <a:avLst/>
@@ -1362,12 +1362,17 @@
           </a:ln>
         </p:spPr>
         <p:txBody>
-          <a:bodyPr wrap="none" lIns="45719" rIns="45719" anchor="ctr">
+          <a:bodyPr wrap="none" lIns="45718" tIns="45718" rIns="45718" bIns="45718" anchor="ctr">
             <a:spAutoFit/>
           </a:bodyPr>
           <a:lstStyle>
             <a:lvl1pPr algn="r">
-              <a:defRPr sz="1200"/>
+              <a:defRPr sz="1200">
+                <a:latin typeface="+mj-lt"/>
+                <a:ea typeface="+mj-ea"/>
+                <a:cs typeface="+mj-cs"/>
+                <a:sym typeface="Calibri"/>
+              </a:defRPr>
             </a:lvl1pPr>
           </a:lstStyle>
           <a:p>
@@ -1883,7 +1888,7 @@
           <a:sym typeface="Calibri"/>
         </a:defRPr>
       </a:lvl1pPr>
-      <a:lvl2pPr marL="0" marR="0" indent="457200" algn="r" defTabSz="914400" rtl="0" latinLnBrk="0">
+      <a:lvl2pPr marL="0" marR="0" indent="0" algn="r" defTabSz="914400" rtl="0" latinLnBrk="0">
         <a:lnSpc>
           <a:spcPct val="100000"/>
         </a:lnSpc>
@@ -1909,7 +1914,7 @@
           <a:sym typeface="Calibri"/>
         </a:defRPr>
       </a:lvl2pPr>
-      <a:lvl3pPr marL="0" marR="0" indent="914400" algn="r" defTabSz="914400" rtl="0" latinLnBrk="0">
+      <a:lvl3pPr marL="0" marR="0" indent="0" algn="r" defTabSz="914400" rtl="0" latinLnBrk="0">
         <a:lnSpc>
           <a:spcPct val="100000"/>
         </a:lnSpc>
@@ -1935,7 +1940,7 @@
           <a:sym typeface="Calibri"/>
         </a:defRPr>
       </a:lvl3pPr>
-      <a:lvl4pPr marL="0" marR="0" indent="1371600" algn="r" defTabSz="914400" rtl="0" latinLnBrk="0">
+      <a:lvl4pPr marL="0" marR="0" indent="0" algn="r" defTabSz="914400" rtl="0" latinLnBrk="0">
         <a:lnSpc>
           <a:spcPct val="100000"/>
         </a:lnSpc>
@@ -1961,7 +1966,7 @@
           <a:sym typeface="Calibri"/>
         </a:defRPr>
       </a:lvl4pPr>
-      <a:lvl5pPr marL="0" marR="0" indent="1828800" algn="r" defTabSz="914400" rtl="0" latinLnBrk="0">
+      <a:lvl5pPr marL="0" marR="0" indent="0" algn="r" defTabSz="914400" rtl="0" latinLnBrk="0">
         <a:lnSpc>
           <a:spcPct val="100000"/>
         </a:lnSpc>
@@ -1987,7 +1992,7 @@
           <a:sym typeface="Calibri"/>
         </a:defRPr>
       </a:lvl5pPr>
-      <a:lvl6pPr marL="0" marR="0" indent="2286000" algn="r" defTabSz="914400" rtl="0" latinLnBrk="0">
+      <a:lvl6pPr marL="0" marR="0" indent="0" algn="r" defTabSz="914400" rtl="0" latinLnBrk="0">
         <a:lnSpc>
           <a:spcPct val="100000"/>
         </a:lnSpc>
@@ -2013,7 +2018,7 @@
           <a:sym typeface="Calibri"/>
         </a:defRPr>
       </a:lvl6pPr>
-      <a:lvl7pPr marL="0" marR="0" indent="2743200" algn="r" defTabSz="914400" rtl="0" latinLnBrk="0">
+      <a:lvl7pPr marL="0" marR="0" indent="0" algn="r" defTabSz="914400" rtl="0" latinLnBrk="0">
         <a:lnSpc>
           <a:spcPct val="100000"/>
         </a:lnSpc>
@@ -2039,7 +2044,7 @@
           <a:sym typeface="Calibri"/>
         </a:defRPr>
       </a:lvl7pPr>
-      <a:lvl8pPr marL="0" marR="0" indent="3200400" algn="r" defTabSz="914400" rtl="0" latinLnBrk="0">
+      <a:lvl8pPr marL="0" marR="0" indent="0" algn="r" defTabSz="914400" rtl="0" latinLnBrk="0">
         <a:lnSpc>
           <a:spcPct val="100000"/>
         </a:lnSpc>
@@ -2065,7 +2070,7 @@
           <a:sym typeface="Calibri"/>
         </a:defRPr>
       </a:lvl8pPr>
-      <a:lvl9pPr marL="0" marR="0" indent="3657600" algn="r" defTabSz="914400" rtl="0" latinLnBrk="0">
+      <a:lvl9pPr marL="0" marR="0" indent="0" algn="r" defTabSz="914400" rtl="0" latinLnBrk="0">
         <a:lnSpc>
           <a:spcPct val="100000"/>
         </a:lnSpc>
@@ -2128,8 +2133,8 @@
         </p:nvSpPr>
         <p:spPr>
           <a:xfrm>
-            <a:off x="731519" y="1864360"/>
-            <a:ext cx="10728657" cy="1117601"/>
+            <a:off x="731518" y="1864360"/>
+            <a:ext cx="10728659" cy="1117601"/>
           </a:xfrm>
           <a:prstGeom prst="rect">
             <a:avLst/>
@@ -2190,8 +2195,8 @@
         </p:nvSpPr>
         <p:spPr>
           <a:xfrm>
-            <a:off x="731519" y="3533229"/>
-            <a:ext cx="10728657" cy="248742"/>
+            <a:off x="731518" y="3533228"/>
+            <a:ext cx="10728659" cy="248743"/>
           </a:xfrm>
           <a:prstGeom prst="rect">
             <a:avLst/>
@@ -2215,6 +2220,10 @@
                 <a:solidFill>
                   <a:srgbClr val="F4A261"/>
                 </a:solidFill>
+                <a:latin typeface="+mj-lt"/>
+                <a:ea typeface="+mj-ea"/>
+                <a:cs typeface="+mj-cs"/>
+                <a:sym typeface="Calibri"/>
               </a:defRPr>
             </a:lvl1pPr>
           </a:lstStyle>
@@ -2234,8 +2243,8 @@
         </p:nvSpPr>
         <p:spPr>
           <a:xfrm>
-            <a:off x="731519" y="4524442"/>
-            <a:ext cx="10728657" cy="186557"/>
+            <a:off x="731518" y="4524442"/>
+            <a:ext cx="10728659" cy="186557"/>
           </a:xfrm>
           <a:prstGeom prst="rect">
             <a:avLst/>
@@ -2259,6 +2268,10 @@
                 <a:solidFill>
                   <a:srgbClr val="FFFFFF"/>
                 </a:solidFill>
+                <a:latin typeface="+mj-lt"/>
+                <a:ea typeface="+mj-ea"/>
+                <a:cs typeface="+mj-cs"/>
+                <a:sym typeface="Calibri"/>
               </a:defRPr>
             </a:lvl1pPr>
           </a:lstStyle>
@@ -2278,8 +2291,8 @@
         </p:nvSpPr>
         <p:spPr>
           <a:xfrm>
-            <a:off x="731519" y="4968679"/>
-            <a:ext cx="10728657" cy="166763"/>
+            <a:off x="731518" y="4968678"/>
+            <a:ext cx="10728659" cy="166763"/>
           </a:xfrm>
           <a:prstGeom prst="rect">
             <a:avLst/>
@@ -2303,13 +2316,17 @@
                 <a:solidFill>
                   <a:srgbClr val="C9D4E8"/>
                 </a:solidFill>
+                <a:latin typeface="+mj-lt"/>
+                <a:ea typeface="+mj-ea"/>
+                <a:cs typeface="+mj-cs"/>
+                <a:sym typeface="Calibri"/>
               </a:defRPr>
             </a:lvl1pPr>
           </a:lstStyle>
           <a:p>
             <a:pPr/>
             <a:r>
-              <a:t>Samudraneel Sarkar · Sakshi Patil · Nikhil Kumar · Manpreet Singh</a:t>
+              <a:t>Samudraneel Sarkar · Patil Sakshi · Nikhil Kumar · Manpreet Kaur</a:t>
             </a:r>
           </a:p>
         </p:txBody>
@@ -2322,8 +2339,8 @@
         </p:nvSpPr>
         <p:spPr>
           <a:xfrm>
-            <a:off x="731519" y="6379385"/>
-            <a:ext cx="10728657" cy="134269"/>
+            <a:off x="731518" y="6379385"/>
+            <a:ext cx="10728659" cy="134268"/>
           </a:xfrm>
           <a:prstGeom prst="rect">
             <a:avLst/>
@@ -2347,6 +2364,10 @@
                 <a:solidFill>
                   <a:srgbClr val="8FA8C8"/>
                 </a:solidFill>
+                <a:latin typeface="+mj-lt"/>
+                <a:ea typeface="+mj-ea"/>
+                <a:cs typeface="+mj-cs"/>
+                <a:sym typeface="Calibri"/>
               </a:defRPr>
             </a:lvl1pPr>
           </a:lstStyle>
@@ -2399,8 +2420,8 @@
         </p:nvSpPr>
         <p:spPr>
           <a:xfrm>
-            <a:off x="731519" y="843279"/>
-            <a:ext cx="10728657" cy="508001"/>
+            <a:off x="731518" y="843278"/>
+            <a:ext cx="10728659" cy="508001"/>
           </a:xfrm>
           <a:prstGeom prst="rect">
             <a:avLst/>
@@ -2447,8 +2468,8 @@
         </p:nvSpPr>
         <p:spPr>
           <a:xfrm>
-            <a:off x="731519" y="1799416"/>
-            <a:ext cx="10728657" cy="241648"/>
+            <a:off x="731518" y="1799415"/>
+            <a:ext cx="10728659" cy="241649"/>
           </a:xfrm>
           <a:prstGeom prst="rect">
             <a:avLst/>
@@ -2472,6 +2493,10 @@
                 <a:solidFill>
                   <a:srgbClr val="F4A261"/>
                 </a:solidFill>
+                <a:latin typeface="+mj-lt"/>
+                <a:ea typeface="+mj-ea"/>
+                <a:cs typeface="+mj-cs"/>
+                <a:sym typeface="Calibri"/>
               </a:defRPr>
             </a:lvl1pPr>
           </a:lstStyle>
@@ -2492,7 +2517,7 @@
         <p:spPr>
           <a:xfrm>
             <a:off x="1371599" y="2514599"/>
-            <a:ext cx="9448497" cy="415158"/>
+            <a:ext cx="9448497" cy="415157"/>
           </a:xfrm>
           <a:prstGeom prst="rect">
             <a:avLst/>
@@ -2517,6 +2542,10 @@
                 <a:solidFill>
                   <a:srgbClr val="F4A261"/>
                 </a:solidFill>
+                <a:latin typeface="+mj-lt"/>
+                <a:ea typeface="+mj-ea"/>
+                <a:cs typeface="+mj-cs"/>
+                <a:sym typeface="Calibri"/>
               </a:defRPr>
             </a:pPr>
             <a:r>
@@ -2567,6 +2596,10 @@
                 <a:solidFill>
                   <a:srgbClr val="F4A261"/>
                 </a:solidFill>
+                <a:latin typeface="+mj-lt"/>
+                <a:ea typeface="+mj-ea"/>
+                <a:cs typeface="+mj-cs"/>
+                <a:sym typeface="Calibri"/>
               </a:defRPr>
             </a:pPr>
             <a:r>
@@ -2617,6 +2650,10 @@
                 <a:solidFill>
                   <a:srgbClr val="F4A261"/>
                 </a:solidFill>
+                <a:latin typeface="+mj-lt"/>
+                <a:ea typeface="+mj-ea"/>
+                <a:cs typeface="+mj-cs"/>
+                <a:sym typeface="Calibri"/>
               </a:defRPr>
             </a:pPr>
             <a:r>
@@ -2641,8 +2678,8 @@
         </p:nvSpPr>
         <p:spPr>
           <a:xfrm>
-            <a:off x="731519" y="5701863"/>
-            <a:ext cx="10728657" cy="209154"/>
+            <a:off x="731518" y="5701862"/>
+            <a:ext cx="10728659" cy="209154"/>
           </a:xfrm>
           <a:prstGeom prst="rect">
             <a:avLst/>
@@ -2666,6 +2703,10 @@
                 <a:solidFill>
                   <a:srgbClr val="FFFFFF"/>
                 </a:solidFill>
+                <a:latin typeface="+mj-lt"/>
+                <a:ea typeface="+mj-ea"/>
+                <a:cs typeface="+mj-cs"/>
+                <a:sym typeface="Calibri"/>
               </a:defRPr>
             </a:lvl1pPr>
           </a:lstStyle>
@@ -2685,8 +2726,8 @@
         </p:nvSpPr>
         <p:spPr>
           <a:xfrm>
-            <a:off x="731519" y="6111679"/>
-            <a:ext cx="10728657" cy="166763"/>
+            <a:off x="731518" y="6111678"/>
+            <a:ext cx="10728659" cy="166763"/>
           </a:xfrm>
           <a:prstGeom prst="rect">
             <a:avLst/>
@@ -2710,6 +2751,10 @@
                 <a:solidFill>
                   <a:srgbClr val="8FA8C8"/>
                 </a:solidFill>
+                <a:latin typeface="+mj-lt"/>
+                <a:ea typeface="+mj-ea"/>
+                <a:cs typeface="+mj-cs"/>
+                <a:sym typeface="Calibri"/>
               </a:defRPr>
             </a:lvl1pPr>
           </a:lstStyle>
@@ -2755,8 +2800,8 @@
         </p:nvSpPr>
         <p:spPr>
           <a:xfrm>
-            <a:off x="548639" y="362634"/>
-            <a:ext cx="11064242" cy="134268"/>
+            <a:off x="548638" y="362633"/>
+            <a:ext cx="11064244" cy="134269"/>
           </a:xfrm>
           <a:prstGeom prst="rect">
             <a:avLst/>
@@ -2780,6 +2825,10 @@
                 <a:solidFill>
                   <a:srgbClr val="1C7293"/>
                 </a:solidFill>
+                <a:latin typeface="+mj-lt"/>
+                <a:ea typeface="+mj-ea"/>
+                <a:cs typeface="+mj-cs"/>
+                <a:sym typeface="Calibri"/>
               </a:defRPr>
             </a:lvl1pPr>
           </a:lstStyle>
@@ -2799,8 +2848,8 @@
         </p:nvSpPr>
         <p:spPr>
           <a:xfrm>
-            <a:off x="548639" y="681227"/>
-            <a:ext cx="11064242" cy="457201"/>
+            <a:off x="548638" y="681227"/>
+            <a:ext cx="11064244" cy="457201"/>
           </a:xfrm>
           <a:prstGeom prst="rect">
             <a:avLst/>
@@ -2876,8 +2925,8 @@
         </p:nvSpPr>
         <p:spPr>
           <a:xfrm>
-            <a:off x="548639" y="3131864"/>
-            <a:ext cx="11064242" cy="137072"/>
+            <a:off x="548638" y="3131864"/>
+            <a:ext cx="11064244" cy="137071"/>
           </a:xfrm>
           <a:prstGeom prst="rect">
             <a:avLst/>
@@ -2901,6 +2950,10 @@
                 <a:solidFill>
                   <a:srgbClr val="5E7183"/>
                 </a:solidFill>
+                <a:latin typeface="+mj-lt"/>
+                <a:ea typeface="+mj-ea"/>
+                <a:cs typeface="+mj-cs"/>
+                <a:sym typeface="Calibri"/>
               </a:defRPr>
             </a:lvl1pPr>
           </a:lstStyle>
@@ -2921,7 +2974,7 @@
         <p:spPr>
           <a:xfrm>
             <a:off x="548640" y="3611879"/>
-            <a:ext cx="3538729" cy="1965961"/>
+            <a:ext cx="3538729" cy="1965962"/>
           </a:xfrm>
           <a:prstGeom prst="roundRect">
             <a:avLst>
@@ -2938,10 +2991,17 @@
           </a:ln>
         </p:spPr>
         <p:txBody>
-          <a:bodyPr lIns="45719" rIns="45719"/>
+          <a:bodyPr lIns="45718" tIns="45718" rIns="45718" bIns="45718"/>
           <a:lstStyle/>
           <a:p>
-            <a:pPr/>
+            <a:pPr>
+              <a:defRPr>
+                <a:latin typeface="+mj-lt"/>
+                <a:ea typeface="+mj-ea"/>
+                <a:cs typeface="+mj-cs"/>
+                <a:sym typeface="Calibri"/>
+              </a:defRPr>
+            </a:pPr>
           </a:p>
         </p:txBody>
       </p:sp>
@@ -2953,8 +3013,8 @@
         </p:nvSpPr>
         <p:spPr>
           <a:xfrm>
-            <a:off x="749807" y="3758184"/>
-            <a:ext cx="3136394" cy="652166"/>
+            <a:off x="749806" y="3758184"/>
+            <a:ext cx="3136396" cy="652166"/>
           </a:xfrm>
           <a:prstGeom prst="rect">
             <a:avLst/>
@@ -2982,6 +3042,10 @@
                 <a:solidFill>
                   <a:srgbClr val="065A82"/>
                 </a:solidFill>
+                <a:latin typeface="+mj-lt"/>
+                <a:ea typeface="+mj-ea"/>
+                <a:cs typeface="+mj-cs"/>
+                <a:sym typeface="Calibri"/>
               </a:defRPr>
             </a:pPr>
             <a:r>
@@ -2997,6 +3061,10 @@
                 <a:solidFill>
                   <a:srgbClr val="1B2A33"/>
                 </a:solidFill>
+                <a:latin typeface="+mj-lt"/>
+                <a:ea typeface="+mj-ea"/>
+                <a:cs typeface="+mj-cs"/>
+                <a:sym typeface="Calibri"/>
               </a:defRPr>
             </a:pPr>
             <a:r>
@@ -3014,7 +3082,7 @@
         <p:spPr>
           <a:xfrm>
             <a:off x="4315967" y="3611879"/>
-            <a:ext cx="3538730" cy="1965961"/>
+            <a:ext cx="3538731" cy="1965962"/>
           </a:xfrm>
           <a:prstGeom prst="roundRect">
             <a:avLst>
@@ -3031,10 +3099,17 @@
           </a:ln>
         </p:spPr>
         <p:txBody>
-          <a:bodyPr lIns="45719" rIns="45719"/>
+          <a:bodyPr lIns="45718" tIns="45718" rIns="45718" bIns="45718"/>
           <a:lstStyle/>
           <a:p>
-            <a:pPr/>
+            <a:pPr>
+              <a:defRPr>
+                <a:latin typeface="+mj-lt"/>
+                <a:ea typeface="+mj-ea"/>
+                <a:cs typeface="+mj-cs"/>
+                <a:sym typeface="Calibri"/>
+              </a:defRPr>
+            </a:pPr>
           </a:p>
         </p:txBody>
       </p:sp>
@@ -3047,7 +3122,7 @@
         <p:spPr>
           <a:xfrm>
             <a:off x="4517135" y="3758184"/>
-            <a:ext cx="3136393" cy="842666"/>
+            <a:ext cx="3136394" cy="842666"/>
           </a:xfrm>
           <a:prstGeom prst="rect">
             <a:avLst/>
@@ -3075,6 +3150,10 @@
                 <a:solidFill>
                   <a:srgbClr val="065A82"/>
                 </a:solidFill>
+                <a:latin typeface="+mj-lt"/>
+                <a:ea typeface="+mj-ea"/>
+                <a:cs typeface="+mj-cs"/>
+                <a:sym typeface="Calibri"/>
               </a:defRPr>
             </a:pPr>
             <a:r>
@@ -3090,6 +3169,10 @@
                 <a:solidFill>
                   <a:srgbClr val="1B2A33"/>
                 </a:solidFill>
+                <a:latin typeface="+mj-lt"/>
+                <a:ea typeface="+mj-ea"/>
+                <a:cs typeface="+mj-cs"/>
+                <a:sym typeface="Calibri"/>
               </a:defRPr>
             </a:pPr>
             <a:r>
@@ -3106,8 +3189,8 @@
         </p:nvSpPr>
         <p:spPr>
           <a:xfrm>
-            <a:off x="8083295" y="3611879"/>
-            <a:ext cx="3538729" cy="1965961"/>
+            <a:off x="8083294" y="3611879"/>
+            <a:ext cx="3538730" cy="1965962"/>
           </a:xfrm>
           <a:prstGeom prst="roundRect">
             <a:avLst>
@@ -3124,10 +3207,17 @@
           </a:ln>
         </p:spPr>
         <p:txBody>
-          <a:bodyPr lIns="45719" rIns="45719"/>
+          <a:bodyPr lIns="45718" tIns="45718" rIns="45718" bIns="45718"/>
           <a:lstStyle/>
           <a:p>
-            <a:pPr/>
+            <a:pPr>
+              <a:defRPr>
+                <a:latin typeface="+mj-lt"/>
+                <a:ea typeface="+mj-ea"/>
+                <a:cs typeface="+mj-cs"/>
+                <a:sym typeface="Calibri"/>
+              </a:defRPr>
+            </a:pPr>
           </a:p>
         </p:txBody>
       </p:sp>
@@ -3140,7 +3230,7 @@
         <p:spPr>
           <a:xfrm>
             <a:off x="8284464" y="3758184"/>
-            <a:ext cx="3136393" cy="842666"/>
+            <a:ext cx="3136394" cy="842666"/>
           </a:xfrm>
           <a:prstGeom prst="rect">
             <a:avLst/>
@@ -3168,6 +3258,10 @@
                 <a:solidFill>
                   <a:srgbClr val="065A82"/>
                 </a:solidFill>
+                <a:latin typeface="+mj-lt"/>
+                <a:ea typeface="+mj-ea"/>
+                <a:cs typeface="+mj-cs"/>
+                <a:sym typeface="Calibri"/>
               </a:defRPr>
             </a:pPr>
             <a:r>
@@ -3183,6 +3277,10 @@
                 <a:solidFill>
                   <a:srgbClr val="1B2A33"/>
                 </a:solidFill>
+                <a:latin typeface="+mj-lt"/>
+                <a:ea typeface="+mj-ea"/>
+                <a:cs typeface="+mj-cs"/>
+                <a:sym typeface="Calibri"/>
               </a:defRPr>
             </a:pPr>
             <a:r>
@@ -3199,8 +3297,8 @@
         </p:nvSpPr>
         <p:spPr>
           <a:xfrm>
-            <a:off x="548639" y="6213392"/>
-            <a:ext cx="11064242" cy="137072"/>
+            <a:off x="548638" y="6213392"/>
+            <a:ext cx="11064244" cy="137071"/>
           </a:xfrm>
           <a:prstGeom prst="rect">
             <a:avLst/>
@@ -3224,6 +3322,10 @@
                 <a:solidFill>
                   <a:srgbClr val="5E7183"/>
                 </a:solidFill>
+                <a:latin typeface="+mj-lt"/>
+                <a:ea typeface="+mj-ea"/>
+                <a:cs typeface="+mj-cs"/>
+                <a:sym typeface="Calibri"/>
               </a:defRPr>
             </a:lvl1pPr>
           </a:lstStyle>
@@ -3243,8 +3345,8 @@
         </p:nvSpPr>
         <p:spPr>
           <a:xfrm>
-            <a:off x="548640" y="6584188"/>
-            <a:ext cx="3657601" cy="127001"/>
+            <a:off x="548639" y="6584188"/>
+            <a:ext cx="3657603" cy="127001"/>
           </a:xfrm>
           <a:prstGeom prst="rect">
             <a:avLst/>
@@ -3268,6 +3370,10 @@
                 <a:solidFill>
                   <a:srgbClr val="5E7183"/>
                 </a:solidFill>
+                <a:latin typeface="+mj-lt"/>
+                <a:ea typeface="+mj-ea"/>
+                <a:cs typeface="+mj-cs"/>
+                <a:sym typeface="Calibri"/>
               </a:defRPr>
             </a:lvl1pPr>
           </a:lstStyle>
@@ -3288,7 +3394,7 @@
         <p:spPr>
           <a:xfrm>
             <a:off x="11277295" y="6584188"/>
-            <a:ext cx="365761" cy="127001"/>
+            <a:ext cx="365762" cy="127001"/>
           </a:xfrm>
           <a:prstGeom prst="rect">
             <a:avLst/>
@@ -3312,6 +3418,10 @@
                 <a:solidFill>
                   <a:srgbClr val="5E7183"/>
                 </a:solidFill>
+                <a:latin typeface="+mj-lt"/>
+                <a:ea typeface="+mj-ea"/>
+                <a:cs typeface="+mj-cs"/>
+                <a:sym typeface="Calibri"/>
               </a:defRPr>
             </a:lvl1pPr>
           </a:lstStyle>
@@ -3357,8 +3467,8 @@
         </p:nvSpPr>
         <p:spPr>
           <a:xfrm>
-            <a:off x="548639" y="362634"/>
-            <a:ext cx="11064242" cy="134268"/>
+            <a:off x="548638" y="362633"/>
+            <a:ext cx="11064244" cy="134269"/>
           </a:xfrm>
           <a:prstGeom prst="rect">
             <a:avLst/>
@@ -3382,6 +3492,10 @@
                 <a:solidFill>
                   <a:srgbClr val="1C7293"/>
                 </a:solidFill>
+                <a:latin typeface="+mj-lt"/>
+                <a:ea typeface="+mj-ea"/>
+                <a:cs typeface="+mj-cs"/>
+                <a:sym typeface="Calibri"/>
               </a:defRPr>
             </a:lvl1pPr>
           </a:lstStyle>
@@ -3401,8 +3515,8 @@
         </p:nvSpPr>
         <p:spPr>
           <a:xfrm>
-            <a:off x="548639" y="681227"/>
-            <a:ext cx="11064242" cy="457201"/>
+            <a:off x="548638" y="681227"/>
+            <a:ext cx="11064244" cy="457201"/>
           </a:xfrm>
           <a:prstGeom prst="rect">
             <a:avLst/>
@@ -3478,8 +3592,8 @@
         </p:nvSpPr>
         <p:spPr>
           <a:xfrm>
-            <a:off x="548639" y="3726224"/>
-            <a:ext cx="5394962" cy="137072"/>
+            <a:off x="548638" y="3726224"/>
+            <a:ext cx="5394964" cy="137071"/>
           </a:xfrm>
           <a:prstGeom prst="rect">
             <a:avLst/>
@@ -3503,6 +3617,10 @@
                 <a:solidFill>
                   <a:srgbClr val="5E7183"/>
                 </a:solidFill>
+                <a:latin typeface="+mj-lt"/>
+                <a:ea typeface="+mj-ea"/>
+                <a:cs typeface="+mj-cs"/>
+                <a:sym typeface="Calibri"/>
               </a:defRPr>
             </a:lvl1pPr>
           </a:lstStyle>
@@ -3522,8 +3640,8 @@
         </p:nvSpPr>
         <p:spPr>
           <a:xfrm>
-            <a:off x="548639" y="4160520"/>
-            <a:ext cx="5394962" cy="1182763"/>
+            <a:off x="548638" y="4160520"/>
+            <a:ext cx="5394964" cy="1182763"/>
           </a:xfrm>
           <a:prstGeom prst="rect">
             <a:avLst/>
@@ -3553,6 +3671,10 @@
                 <a:solidFill>
                   <a:srgbClr val="1B2A33"/>
                 </a:solidFill>
+                <a:latin typeface="+mj-lt"/>
+                <a:ea typeface="+mj-ea"/>
+                <a:cs typeface="+mj-cs"/>
+                <a:sym typeface="Calibri"/>
               </a:defRPr>
             </a:pPr>
             <a:r>
@@ -3570,6 +3692,10 @@
                 <a:solidFill>
                   <a:srgbClr val="1B2A33"/>
                 </a:solidFill>
+                <a:latin typeface="+mj-lt"/>
+                <a:ea typeface="+mj-ea"/>
+                <a:cs typeface="+mj-cs"/>
+                <a:sym typeface="Calibri"/>
               </a:defRPr>
             </a:pPr>
             <a:r>
@@ -3587,6 +3713,10 @@
                 <a:solidFill>
                   <a:srgbClr val="1B2A33"/>
                 </a:solidFill>
+                <a:latin typeface="+mj-lt"/>
+                <a:ea typeface="+mj-ea"/>
+                <a:cs typeface="+mj-cs"/>
+                <a:sym typeface="Calibri"/>
               </a:defRPr>
             </a:pPr>
             <a:r>
@@ -3621,10 +3751,17 @@
           </a:ln>
         </p:spPr>
         <p:txBody>
-          <a:bodyPr lIns="45719" rIns="45719"/>
+          <a:bodyPr lIns="45718" tIns="45718" rIns="45718" bIns="45718"/>
           <a:lstStyle/>
           <a:p>
-            <a:pPr/>
+            <a:pPr>
+              <a:defRPr>
+                <a:latin typeface="+mj-lt"/>
+                <a:ea typeface="+mj-ea"/>
+                <a:cs typeface="+mj-cs"/>
+                <a:sym typeface="Calibri"/>
+              </a:defRPr>
+            </a:pPr>
           </a:p>
         </p:txBody>
       </p:sp>
@@ -3637,7 +3774,7 @@
         <p:spPr>
           <a:xfrm>
             <a:off x="6601968" y="1563624"/>
-            <a:ext cx="4809745" cy="652165"/>
+            <a:ext cx="4809746" cy="652165"/>
           </a:xfrm>
           <a:prstGeom prst="rect">
             <a:avLst/>
@@ -3665,6 +3802,10 @@
                 <a:solidFill>
                   <a:srgbClr val="065A82"/>
                 </a:solidFill>
+                <a:latin typeface="+mj-lt"/>
+                <a:ea typeface="+mj-ea"/>
+                <a:cs typeface="+mj-cs"/>
+                <a:sym typeface="Calibri"/>
               </a:defRPr>
             </a:pPr>
             <a:r>
@@ -3680,6 +3821,10 @@
                 <a:solidFill>
                   <a:srgbClr val="1B2A33"/>
                 </a:solidFill>
+                <a:latin typeface="+mj-lt"/>
+                <a:ea typeface="+mj-ea"/>
+                <a:cs typeface="+mj-cs"/>
+                <a:sym typeface="Calibri"/>
               </a:defRPr>
             </a:pPr>
             <a:r>
@@ -3697,7 +3842,7 @@
         <p:spPr>
           <a:xfrm>
             <a:off x="6400800" y="3008376"/>
-            <a:ext cx="5212080" cy="1371601"/>
+            <a:ext cx="5212080" cy="1371602"/>
           </a:xfrm>
           <a:prstGeom prst="roundRect">
             <a:avLst>
@@ -3714,10 +3859,17 @@
           </a:ln>
         </p:spPr>
         <p:txBody>
-          <a:bodyPr lIns="45719" rIns="45719"/>
+          <a:bodyPr lIns="45718" tIns="45718" rIns="45718" bIns="45718"/>
           <a:lstStyle/>
           <a:p>
-            <a:pPr/>
+            <a:pPr>
+              <a:defRPr>
+                <a:latin typeface="+mj-lt"/>
+                <a:ea typeface="+mj-ea"/>
+                <a:cs typeface="+mj-cs"/>
+                <a:sym typeface="Calibri"/>
+              </a:defRPr>
+            </a:pPr>
           </a:p>
         </p:txBody>
       </p:sp>
@@ -3729,8 +3881,8 @@
         </p:nvSpPr>
         <p:spPr>
           <a:xfrm>
-            <a:off x="6601968" y="3154679"/>
-            <a:ext cx="4809745" cy="652166"/>
+            <a:off x="6601968" y="3154678"/>
+            <a:ext cx="4809746" cy="652166"/>
           </a:xfrm>
           <a:prstGeom prst="rect">
             <a:avLst/>
@@ -3758,6 +3910,10 @@
                 <a:solidFill>
                   <a:srgbClr val="065A82"/>
                 </a:solidFill>
+                <a:latin typeface="+mj-lt"/>
+                <a:ea typeface="+mj-ea"/>
+                <a:cs typeface="+mj-cs"/>
+                <a:sym typeface="Calibri"/>
               </a:defRPr>
             </a:pPr>
             <a:r>
@@ -3773,6 +3929,10 @@
                 <a:solidFill>
                   <a:srgbClr val="1B2A33"/>
                 </a:solidFill>
+                <a:latin typeface="+mj-lt"/>
+                <a:ea typeface="+mj-ea"/>
+                <a:cs typeface="+mj-cs"/>
+                <a:sym typeface="Calibri"/>
               </a:defRPr>
             </a:pPr>
             <a:r>
@@ -3790,7 +3950,7 @@
         <p:spPr>
           <a:xfrm>
             <a:off x="6400800" y="4599432"/>
-            <a:ext cx="5212080" cy="1371601"/>
+            <a:ext cx="5212080" cy="1371602"/>
           </a:xfrm>
           <a:prstGeom prst="roundRect">
             <a:avLst>
@@ -3807,10 +3967,17 @@
           </a:ln>
         </p:spPr>
         <p:txBody>
-          <a:bodyPr lIns="45719" rIns="45719"/>
+          <a:bodyPr lIns="45718" tIns="45718" rIns="45718" bIns="45718"/>
           <a:lstStyle/>
           <a:p>
-            <a:pPr/>
+            <a:pPr>
+              <a:defRPr>
+                <a:latin typeface="+mj-lt"/>
+                <a:ea typeface="+mj-ea"/>
+                <a:cs typeface="+mj-cs"/>
+                <a:sym typeface="Calibri"/>
+              </a:defRPr>
+            </a:pPr>
           </a:p>
         </p:txBody>
       </p:sp>
@@ -3823,7 +3990,7 @@
         <p:spPr>
           <a:xfrm>
             <a:off x="6601968" y="4745735"/>
-            <a:ext cx="4809745" cy="652166"/>
+            <a:ext cx="4809746" cy="652165"/>
           </a:xfrm>
           <a:prstGeom prst="rect">
             <a:avLst/>
@@ -3851,6 +4018,10 @@
                 <a:solidFill>
                   <a:srgbClr val="065A82"/>
                 </a:solidFill>
+                <a:latin typeface="+mj-lt"/>
+                <a:ea typeface="+mj-ea"/>
+                <a:cs typeface="+mj-cs"/>
+                <a:sym typeface="Calibri"/>
               </a:defRPr>
             </a:pPr>
             <a:r>
@@ -3866,6 +4037,10 @@
                 <a:solidFill>
                   <a:srgbClr val="1B2A33"/>
                 </a:solidFill>
+                <a:latin typeface="+mj-lt"/>
+                <a:ea typeface="+mj-ea"/>
+                <a:cs typeface="+mj-cs"/>
+                <a:sym typeface="Calibri"/>
               </a:defRPr>
             </a:pPr>
             <a:r>
@@ -3882,8 +4057,8 @@
         </p:nvSpPr>
         <p:spPr>
           <a:xfrm>
-            <a:off x="548640" y="6584188"/>
-            <a:ext cx="3657601" cy="127001"/>
+            <a:off x="548639" y="6584188"/>
+            <a:ext cx="3657603" cy="127001"/>
           </a:xfrm>
           <a:prstGeom prst="rect">
             <a:avLst/>
@@ -3907,6 +4082,10 @@
                 <a:solidFill>
                   <a:srgbClr val="5E7183"/>
                 </a:solidFill>
+                <a:latin typeface="+mj-lt"/>
+                <a:ea typeface="+mj-ea"/>
+                <a:cs typeface="+mj-cs"/>
+                <a:sym typeface="Calibri"/>
               </a:defRPr>
             </a:lvl1pPr>
           </a:lstStyle>
@@ -3927,7 +4106,7 @@
         <p:spPr>
           <a:xfrm>
             <a:off x="11277295" y="6584188"/>
-            <a:ext cx="365761" cy="127001"/>
+            <a:ext cx="365762" cy="127001"/>
           </a:xfrm>
           <a:prstGeom prst="rect">
             <a:avLst/>
@@ -3951,6 +4130,10 @@
                 <a:solidFill>
                   <a:srgbClr val="5E7183"/>
                 </a:solidFill>
+                <a:latin typeface="+mj-lt"/>
+                <a:ea typeface="+mj-ea"/>
+                <a:cs typeface="+mj-cs"/>
+                <a:sym typeface="Calibri"/>
               </a:defRPr>
             </a:lvl1pPr>
           </a:lstStyle>
@@ -3996,8 +4179,8 @@
         </p:nvSpPr>
         <p:spPr>
           <a:xfrm>
-            <a:off x="548639" y="362634"/>
-            <a:ext cx="11064242" cy="134268"/>
+            <a:off x="548638" y="362633"/>
+            <a:ext cx="11064244" cy="134269"/>
           </a:xfrm>
           <a:prstGeom prst="rect">
             <a:avLst/>
@@ -4021,6 +4204,10 @@
                 <a:solidFill>
                   <a:srgbClr val="1C7293"/>
                 </a:solidFill>
+                <a:latin typeface="+mj-lt"/>
+                <a:ea typeface="+mj-ea"/>
+                <a:cs typeface="+mj-cs"/>
+                <a:sym typeface="Calibri"/>
               </a:defRPr>
             </a:lvl1pPr>
           </a:lstStyle>
@@ -4040,8 +4227,8 @@
         </p:nvSpPr>
         <p:spPr>
           <a:xfrm>
-            <a:off x="548639" y="681227"/>
-            <a:ext cx="11064242" cy="457201"/>
+            <a:off x="548638" y="681227"/>
+            <a:ext cx="11064244" cy="457201"/>
           </a:xfrm>
           <a:prstGeom prst="rect">
             <a:avLst/>
@@ -4089,7 +4276,7 @@
         <p:spPr>
           <a:xfrm>
             <a:off x="548640" y="1371600"/>
-            <a:ext cx="5440680" cy="1508761"/>
+            <a:ext cx="5440680" cy="1508762"/>
           </a:xfrm>
           <a:prstGeom prst="roundRect">
             <a:avLst>
@@ -4106,10 +4293,17 @@
           </a:ln>
         </p:spPr>
         <p:txBody>
-          <a:bodyPr lIns="45719" rIns="45719"/>
+          <a:bodyPr lIns="45718" tIns="45718" rIns="45718" bIns="45718"/>
           <a:lstStyle/>
           <a:p>
-            <a:pPr/>
+            <a:pPr>
+              <a:defRPr>
+                <a:latin typeface="+mj-lt"/>
+                <a:ea typeface="+mj-ea"/>
+                <a:cs typeface="+mj-cs"/>
+                <a:sym typeface="Calibri"/>
+              </a:defRPr>
+            </a:pPr>
           </a:p>
         </p:txBody>
       </p:sp>
@@ -4121,8 +4315,8 @@
         </p:nvSpPr>
         <p:spPr>
           <a:xfrm>
-            <a:off x="749808" y="1517903"/>
-            <a:ext cx="5038345" cy="652166"/>
+            <a:off x="749807" y="1517902"/>
+            <a:ext cx="5038347" cy="652166"/>
           </a:xfrm>
           <a:prstGeom prst="rect">
             <a:avLst/>
@@ -4150,6 +4344,10 @@
                 <a:solidFill>
                   <a:srgbClr val="065A82"/>
                 </a:solidFill>
+                <a:latin typeface="+mj-lt"/>
+                <a:ea typeface="+mj-ea"/>
+                <a:cs typeface="+mj-cs"/>
+                <a:sym typeface="Calibri"/>
               </a:defRPr>
             </a:pPr>
             <a:r>
@@ -4165,6 +4363,10 @@
                 <a:solidFill>
                   <a:srgbClr val="1B2A33"/>
                 </a:solidFill>
+                <a:latin typeface="+mj-lt"/>
+                <a:ea typeface="+mj-ea"/>
+                <a:cs typeface="+mj-cs"/>
+                <a:sym typeface="Calibri"/>
               </a:defRPr>
             </a:pPr>
             <a:r>
@@ -4182,7 +4384,7 @@
         <p:spPr>
           <a:xfrm>
             <a:off x="6217920" y="1371600"/>
-            <a:ext cx="5440680" cy="1508761"/>
+            <a:ext cx="5440680" cy="1508762"/>
           </a:xfrm>
           <a:prstGeom prst="roundRect">
             <a:avLst>
@@ -4199,10 +4401,17 @@
           </a:ln>
         </p:spPr>
         <p:txBody>
-          <a:bodyPr lIns="45719" rIns="45719"/>
+          <a:bodyPr lIns="45718" tIns="45718" rIns="45718" bIns="45718"/>
           <a:lstStyle/>
           <a:p>
-            <a:pPr/>
+            <a:pPr>
+              <a:defRPr>
+                <a:latin typeface="+mj-lt"/>
+                <a:ea typeface="+mj-ea"/>
+                <a:cs typeface="+mj-cs"/>
+                <a:sym typeface="Calibri"/>
+              </a:defRPr>
+            </a:pPr>
           </a:p>
         </p:txBody>
       </p:sp>
@@ -4214,8 +4423,8 @@
         </p:nvSpPr>
         <p:spPr>
           <a:xfrm>
-            <a:off x="6419088" y="1517903"/>
-            <a:ext cx="5038345" cy="842666"/>
+            <a:off x="6419087" y="1517902"/>
+            <a:ext cx="5038347" cy="842666"/>
           </a:xfrm>
           <a:prstGeom prst="rect">
             <a:avLst/>
@@ -4243,6 +4452,10 @@
                 <a:solidFill>
                   <a:srgbClr val="065A82"/>
                 </a:solidFill>
+                <a:latin typeface="+mj-lt"/>
+                <a:ea typeface="+mj-ea"/>
+                <a:cs typeface="+mj-cs"/>
+                <a:sym typeface="Calibri"/>
               </a:defRPr>
             </a:pPr>
             <a:r>
@@ -4258,6 +4471,10 @@
                 <a:solidFill>
                   <a:srgbClr val="1B2A33"/>
                 </a:solidFill>
+                <a:latin typeface="+mj-lt"/>
+                <a:ea typeface="+mj-ea"/>
+                <a:cs typeface="+mj-cs"/>
+                <a:sym typeface="Calibri"/>
               </a:defRPr>
             </a:pPr>
             <a:r>
@@ -4274,8 +4491,8 @@
         </p:nvSpPr>
         <p:spPr>
           <a:xfrm>
-            <a:off x="548639" y="3322759"/>
-            <a:ext cx="11064242" cy="166763"/>
+            <a:off x="548638" y="3322758"/>
+            <a:ext cx="11064244" cy="166763"/>
           </a:xfrm>
           <a:prstGeom prst="rect">
             <a:avLst/>
@@ -4299,6 +4516,10 @@
                 <a:solidFill>
                   <a:srgbClr val="1B2A33"/>
                 </a:solidFill>
+                <a:latin typeface="+mj-lt"/>
+                <a:ea typeface="+mj-ea"/>
+                <a:cs typeface="+mj-cs"/>
+                <a:sym typeface="Calibri"/>
               </a:defRPr>
             </a:lvl1pPr>
           </a:lstStyle>
@@ -4319,7 +4540,7 @@
         <p:spPr>
           <a:xfrm>
             <a:off x="548640" y="3657600"/>
-            <a:ext cx="3538729" cy="1965961"/>
+            <a:ext cx="3538729" cy="1965962"/>
           </a:xfrm>
           <a:prstGeom prst="roundRect">
             <a:avLst>
@@ -4336,10 +4557,17 @@
           </a:ln>
         </p:spPr>
         <p:txBody>
-          <a:bodyPr lIns="45719" rIns="45719"/>
+          <a:bodyPr lIns="45718" tIns="45718" rIns="45718" bIns="45718"/>
           <a:lstStyle/>
           <a:p>
-            <a:pPr/>
+            <a:pPr>
+              <a:defRPr>
+                <a:latin typeface="+mj-lt"/>
+                <a:ea typeface="+mj-ea"/>
+                <a:cs typeface="+mj-cs"/>
+                <a:sym typeface="Calibri"/>
+              </a:defRPr>
+            </a:pPr>
           </a:p>
         </p:txBody>
       </p:sp>
@@ -4351,8 +4579,8 @@
         </p:nvSpPr>
         <p:spPr>
           <a:xfrm>
-            <a:off x="749807" y="3803903"/>
-            <a:ext cx="3136394" cy="1033166"/>
+            <a:off x="749806" y="3803903"/>
+            <a:ext cx="3136396" cy="1033165"/>
           </a:xfrm>
           <a:prstGeom prst="rect">
             <a:avLst/>
@@ -4380,6 +4608,10 @@
                 <a:solidFill>
                   <a:srgbClr val="065A82"/>
                 </a:solidFill>
+                <a:latin typeface="+mj-lt"/>
+                <a:ea typeface="+mj-ea"/>
+                <a:cs typeface="+mj-cs"/>
+                <a:sym typeface="Calibri"/>
               </a:defRPr>
             </a:pPr>
             <a:r>
@@ -4395,6 +4627,10 @@
                 <a:solidFill>
                   <a:srgbClr val="1B2A33"/>
                 </a:solidFill>
+                <a:latin typeface="+mj-lt"/>
+                <a:ea typeface="+mj-ea"/>
+                <a:cs typeface="+mj-cs"/>
+                <a:sym typeface="Calibri"/>
               </a:defRPr>
             </a:pPr>
             <a:r>
@@ -4412,7 +4648,7 @@
         <p:spPr>
           <a:xfrm>
             <a:off x="4315967" y="3657600"/>
-            <a:ext cx="3538730" cy="1965961"/>
+            <a:ext cx="3538731" cy="1965962"/>
           </a:xfrm>
           <a:prstGeom prst="roundRect">
             <a:avLst>
@@ -4429,10 +4665,17 @@
           </a:ln>
         </p:spPr>
         <p:txBody>
-          <a:bodyPr lIns="45719" rIns="45719"/>
+          <a:bodyPr lIns="45718" tIns="45718" rIns="45718" bIns="45718"/>
           <a:lstStyle/>
           <a:p>
-            <a:pPr/>
+            <a:pPr>
+              <a:defRPr>
+                <a:latin typeface="+mj-lt"/>
+                <a:ea typeface="+mj-ea"/>
+                <a:cs typeface="+mj-cs"/>
+                <a:sym typeface="Calibri"/>
+              </a:defRPr>
+            </a:pPr>
           </a:p>
         </p:txBody>
       </p:sp>
@@ -4445,7 +4688,7 @@
         <p:spPr>
           <a:xfrm>
             <a:off x="4517135" y="3803903"/>
-            <a:ext cx="3136393" cy="842666"/>
+            <a:ext cx="3136394" cy="842665"/>
           </a:xfrm>
           <a:prstGeom prst="rect">
             <a:avLst/>
@@ -4473,6 +4716,10 @@
                 <a:solidFill>
                   <a:srgbClr val="065A82"/>
                 </a:solidFill>
+                <a:latin typeface="+mj-lt"/>
+                <a:ea typeface="+mj-ea"/>
+                <a:cs typeface="+mj-cs"/>
+                <a:sym typeface="Calibri"/>
               </a:defRPr>
             </a:pPr>
             <a:r>
@@ -4488,6 +4735,10 @@
                 <a:solidFill>
                   <a:srgbClr val="1B2A33"/>
                 </a:solidFill>
+                <a:latin typeface="+mj-lt"/>
+                <a:ea typeface="+mj-ea"/>
+                <a:cs typeface="+mj-cs"/>
+                <a:sym typeface="Calibri"/>
               </a:defRPr>
             </a:pPr>
             <a:r>
@@ -4504,8 +4755,8 @@
         </p:nvSpPr>
         <p:spPr>
           <a:xfrm>
-            <a:off x="8083295" y="3657600"/>
-            <a:ext cx="3538729" cy="1965961"/>
+            <a:off x="8083294" y="3657600"/>
+            <a:ext cx="3538730" cy="1965962"/>
           </a:xfrm>
           <a:prstGeom prst="roundRect">
             <a:avLst>
@@ -4522,10 +4773,17 @@
           </a:ln>
         </p:spPr>
         <p:txBody>
-          <a:bodyPr lIns="45719" rIns="45719"/>
+          <a:bodyPr lIns="45718" tIns="45718" rIns="45718" bIns="45718"/>
           <a:lstStyle/>
           <a:p>
-            <a:pPr/>
+            <a:pPr>
+              <a:defRPr>
+                <a:latin typeface="+mj-lt"/>
+                <a:ea typeface="+mj-ea"/>
+                <a:cs typeface="+mj-cs"/>
+                <a:sym typeface="Calibri"/>
+              </a:defRPr>
+            </a:pPr>
           </a:p>
         </p:txBody>
       </p:sp>
@@ -4538,7 +4796,7 @@
         <p:spPr>
           <a:xfrm>
             <a:off x="8284464" y="3803903"/>
-            <a:ext cx="3136393" cy="842666"/>
+            <a:ext cx="3136394" cy="842665"/>
           </a:xfrm>
           <a:prstGeom prst="rect">
             <a:avLst/>
@@ -4566,6 +4824,10 @@
                 <a:solidFill>
                   <a:srgbClr val="065A82"/>
                 </a:solidFill>
+                <a:latin typeface="+mj-lt"/>
+                <a:ea typeface="+mj-ea"/>
+                <a:cs typeface="+mj-cs"/>
+                <a:sym typeface="Calibri"/>
               </a:defRPr>
             </a:pPr>
             <a:r>
@@ -4581,6 +4843,10 @@
                 <a:solidFill>
                   <a:srgbClr val="1B2A33"/>
                 </a:solidFill>
+                <a:latin typeface="+mj-lt"/>
+                <a:ea typeface="+mj-ea"/>
+                <a:cs typeface="+mj-cs"/>
+                <a:sym typeface="Calibri"/>
               </a:defRPr>
             </a:pPr>
             <a:r>
@@ -4597,8 +4863,8 @@
         </p:nvSpPr>
         <p:spPr>
           <a:xfrm>
-            <a:off x="548640" y="6584188"/>
-            <a:ext cx="3657601" cy="127001"/>
+            <a:off x="548639" y="6584188"/>
+            <a:ext cx="3657603" cy="127001"/>
           </a:xfrm>
           <a:prstGeom prst="rect">
             <a:avLst/>
@@ -4622,6 +4888,10 @@
                 <a:solidFill>
                   <a:srgbClr val="5E7183"/>
                 </a:solidFill>
+                <a:latin typeface="+mj-lt"/>
+                <a:ea typeface="+mj-ea"/>
+                <a:cs typeface="+mj-cs"/>
+                <a:sym typeface="Calibri"/>
               </a:defRPr>
             </a:lvl1pPr>
           </a:lstStyle>
@@ -4642,7 +4912,7 @@
         <p:spPr>
           <a:xfrm>
             <a:off x="11277295" y="6584188"/>
-            <a:ext cx="365761" cy="127001"/>
+            <a:ext cx="365762" cy="127001"/>
           </a:xfrm>
           <a:prstGeom prst="rect">
             <a:avLst/>
@@ -4666,6 +4936,10 @@
                 <a:solidFill>
                   <a:srgbClr val="5E7183"/>
                 </a:solidFill>
+                <a:latin typeface="+mj-lt"/>
+                <a:ea typeface="+mj-ea"/>
+                <a:cs typeface="+mj-cs"/>
+                <a:sym typeface="Calibri"/>
               </a:defRPr>
             </a:lvl1pPr>
           </a:lstStyle>
@@ -4711,8 +4985,8 @@
         </p:nvSpPr>
         <p:spPr>
           <a:xfrm>
-            <a:off x="548639" y="362634"/>
-            <a:ext cx="11064242" cy="134268"/>
+            <a:off x="548638" y="362633"/>
+            <a:ext cx="11064244" cy="134269"/>
           </a:xfrm>
           <a:prstGeom prst="rect">
             <a:avLst/>
@@ -4736,6 +5010,10 @@
                 <a:solidFill>
                   <a:srgbClr val="1C7293"/>
                 </a:solidFill>
+                <a:latin typeface="+mj-lt"/>
+                <a:ea typeface="+mj-ea"/>
+                <a:cs typeface="+mj-cs"/>
+                <a:sym typeface="Calibri"/>
               </a:defRPr>
             </a:lvl1pPr>
           </a:lstStyle>
@@ -4755,8 +5033,8 @@
         </p:nvSpPr>
         <p:spPr>
           <a:xfrm>
-            <a:off x="548639" y="681227"/>
-            <a:ext cx="11064242" cy="457201"/>
+            <a:off x="548638" y="681227"/>
+            <a:ext cx="11064244" cy="457201"/>
           </a:xfrm>
           <a:prstGeom prst="rect">
             <a:avLst/>
@@ -4803,8 +5081,8 @@
         </p:nvSpPr>
         <p:spPr>
           <a:xfrm>
-            <a:off x="548639" y="1554479"/>
-            <a:ext cx="5303522" cy="2551560"/>
+            <a:off x="548638" y="1554478"/>
+            <a:ext cx="5303523" cy="2551560"/>
           </a:xfrm>
           <a:prstGeom prst="rect">
             <a:avLst/>
@@ -4834,6 +5112,10 @@
                 <a:solidFill>
                   <a:srgbClr val="1B2A33"/>
                 </a:solidFill>
+                <a:latin typeface="+mj-lt"/>
+                <a:ea typeface="+mj-ea"/>
+                <a:cs typeface="+mj-cs"/>
+                <a:sym typeface="Calibri"/>
               </a:defRPr>
             </a:pPr>
             <a:r>
@@ -4851,6 +5133,10 @@
                 <a:solidFill>
                   <a:srgbClr val="1B2A33"/>
                 </a:solidFill>
+                <a:latin typeface="+mj-lt"/>
+                <a:ea typeface="+mj-ea"/>
+                <a:cs typeface="+mj-cs"/>
+                <a:sym typeface="Calibri"/>
               </a:defRPr>
             </a:pPr>
             <a:r>
@@ -4868,6 +5154,10 @@
                 <a:solidFill>
                   <a:srgbClr val="1B2A33"/>
                 </a:solidFill>
+                <a:latin typeface="+mj-lt"/>
+                <a:ea typeface="+mj-ea"/>
+                <a:cs typeface="+mj-cs"/>
+                <a:sym typeface="Calibri"/>
               </a:defRPr>
             </a:pPr>
             <a:r>
@@ -4885,6 +5175,10 @@
                 <a:solidFill>
                   <a:srgbClr val="1B2A33"/>
                 </a:solidFill>
+                <a:latin typeface="+mj-lt"/>
+                <a:ea typeface="+mj-ea"/>
+                <a:cs typeface="+mj-cs"/>
+                <a:sym typeface="Calibri"/>
               </a:defRPr>
             </a:pPr>
             <a:r>
@@ -5956,7 +6250,7 @@
         <p:spPr>
           <a:xfrm>
             <a:off x="6309359" y="4069124"/>
-            <a:ext cx="5212081" cy="137072"/>
+            <a:ext cx="5212082" cy="137071"/>
           </a:xfrm>
           <a:prstGeom prst="rect">
             <a:avLst/>
@@ -5980,6 +6274,10 @@
                 <a:solidFill>
                   <a:srgbClr val="5E7183"/>
                 </a:solidFill>
+                <a:latin typeface="+mj-lt"/>
+                <a:ea typeface="+mj-ea"/>
+                <a:cs typeface="+mj-cs"/>
+                <a:sym typeface="Calibri"/>
               </a:defRPr>
             </a:lvl1pPr>
           </a:lstStyle>
@@ -5999,8 +6297,8 @@
         </p:nvSpPr>
         <p:spPr>
           <a:xfrm>
-            <a:off x="6309359" y="4660899"/>
-            <a:ext cx="5212081" cy="508001"/>
+            <a:off x="6309359" y="4660898"/>
+            <a:ext cx="5212082" cy="508001"/>
           </a:xfrm>
           <a:prstGeom prst="rect">
             <a:avLst/>
@@ -6048,7 +6346,7 @@
         <p:spPr>
           <a:xfrm>
             <a:off x="6309359" y="5349240"/>
-            <a:ext cx="5212081" cy="156865"/>
+            <a:ext cx="5212082" cy="156865"/>
           </a:xfrm>
           <a:prstGeom prst="rect">
             <a:avLst/>
@@ -6072,6 +6370,10 @@
                 <a:solidFill>
                   <a:srgbClr val="1B2A33"/>
                 </a:solidFill>
+                <a:latin typeface="+mj-lt"/>
+                <a:ea typeface="+mj-ea"/>
+                <a:cs typeface="+mj-cs"/>
+                <a:sym typeface="Calibri"/>
               </a:defRPr>
             </a:lvl1pPr>
           </a:lstStyle>
@@ -6091,8 +6393,8 @@
         </p:nvSpPr>
         <p:spPr>
           <a:xfrm>
-            <a:off x="548640" y="6584188"/>
-            <a:ext cx="3657601" cy="127001"/>
+            <a:off x="548639" y="6584188"/>
+            <a:ext cx="3657603" cy="127001"/>
           </a:xfrm>
           <a:prstGeom prst="rect">
             <a:avLst/>
@@ -6116,6 +6418,10 @@
                 <a:solidFill>
                   <a:srgbClr val="5E7183"/>
                 </a:solidFill>
+                <a:latin typeface="+mj-lt"/>
+                <a:ea typeface="+mj-ea"/>
+                <a:cs typeface="+mj-cs"/>
+                <a:sym typeface="Calibri"/>
               </a:defRPr>
             </a:lvl1pPr>
           </a:lstStyle>
@@ -6136,7 +6442,7 @@
         <p:spPr>
           <a:xfrm>
             <a:off x="11277295" y="6584188"/>
-            <a:ext cx="365761" cy="127001"/>
+            <a:ext cx="365762" cy="127001"/>
           </a:xfrm>
           <a:prstGeom prst="rect">
             <a:avLst/>
@@ -6160,6 +6466,10 @@
                 <a:solidFill>
                   <a:srgbClr val="5E7183"/>
                 </a:solidFill>
+                <a:latin typeface="+mj-lt"/>
+                <a:ea typeface="+mj-ea"/>
+                <a:cs typeface="+mj-cs"/>
+                <a:sym typeface="Calibri"/>
               </a:defRPr>
             </a:lvl1pPr>
           </a:lstStyle>
@@ -6205,8 +6515,8 @@
         </p:nvSpPr>
         <p:spPr>
           <a:xfrm>
-            <a:off x="548639" y="362634"/>
-            <a:ext cx="11064242" cy="134268"/>
+            <a:off x="548638" y="362633"/>
+            <a:ext cx="11064244" cy="134269"/>
           </a:xfrm>
           <a:prstGeom prst="rect">
             <a:avLst/>
@@ -6230,6 +6540,10 @@
                 <a:solidFill>
                   <a:srgbClr val="1C7293"/>
                 </a:solidFill>
+                <a:latin typeface="+mj-lt"/>
+                <a:ea typeface="+mj-ea"/>
+                <a:cs typeface="+mj-cs"/>
+                <a:sym typeface="Calibri"/>
               </a:defRPr>
             </a:lvl1pPr>
           </a:lstStyle>
@@ -6249,8 +6563,8 @@
         </p:nvSpPr>
         <p:spPr>
           <a:xfrm>
-            <a:off x="548639" y="681227"/>
-            <a:ext cx="11064242" cy="457201"/>
+            <a:off x="548638" y="681227"/>
+            <a:ext cx="11064244" cy="457201"/>
           </a:xfrm>
           <a:prstGeom prst="rect">
             <a:avLst/>
@@ -6326,8 +6640,8 @@
         </p:nvSpPr>
         <p:spPr>
           <a:xfrm>
-            <a:off x="548639" y="3269024"/>
-            <a:ext cx="11064242" cy="137072"/>
+            <a:off x="548638" y="3269024"/>
+            <a:ext cx="11064244" cy="137071"/>
           </a:xfrm>
           <a:prstGeom prst="rect">
             <a:avLst/>
@@ -6351,6 +6665,10 @@
                 <a:solidFill>
                   <a:srgbClr val="5E7183"/>
                 </a:solidFill>
+                <a:latin typeface="+mj-lt"/>
+                <a:ea typeface="+mj-ea"/>
+                <a:cs typeface="+mj-cs"/>
+                <a:sym typeface="Calibri"/>
               </a:defRPr>
             </a:lvl1pPr>
           </a:lstStyle>
@@ -6370,7 +6688,7 @@
         </p:nvGraphicFramePr>
         <p:xfrm>
           <a:off x="548640" y="3703320"/>
-          <a:ext cx="5394960" cy="1920241"/>
+          <a:ext cx="5394960" cy="1920242"/>
         </p:xfrm>
         <a:graphic xmlns:a="http://schemas.openxmlformats.org/drawingml/2006/main">
           <a:graphicData uri="http://schemas.openxmlformats.org/drawingml/2006/table">
@@ -7254,8 +7572,8 @@
         </p:nvSpPr>
         <p:spPr>
           <a:xfrm>
-            <a:off x="548639" y="5737904"/>
-            <a:ext cx="5394962" cy="137072"/>
+            <a:off x="548638" y="5737904"/>
+            <a:ext cx="5394964" cy="137071"/>
           </a:xfrm>
           <a:prstGeom prst="rect">
             <a:avLst/>
@@ -7279,6 +7597,10 @@
                 <a:solidFill>
                   <a:srgbClr val="5E7183"/>
                 </a:solidFill>
+                <a:latin typeface="+mj-lt"/>
+                <a:ea typeface="+mj-ea"/>
+                <a:cs typeface="+mj-cs"/>
+                <a:sym typeface="Calibri"/>
               </a:defRPr>
             </a:lvl1pPr>
           </a:lstStyle>
@@ -7298,8 +7620,8 @@
         </p:nvSpPr>
         <p:spPr>
           <a:xfrm>
-            <a:off x="6400799" y="3684270"/>
-            <a:ext cx="5120642" cy="723901"/>
+            <a:off x="6400798" y="3684270"/>
+            <a:ext cx="5120643" cy="723901"/>
           </a:xfrm>
           <a:prstGeom prst="rect">
             <a:avLst/>
@@ -7346,8 +7668,8 @@
         </p:nvSpPr>
         <p:spPr>
           <a:xfrm>
-            <a:off x="6400799" y="4480559"/>
-            <a:ext cx="5120642" cy="156866"/>
+            <a:off x="6400798" y="4480559"/>
+            <a:ext cx="5120643" cy="156865"/>
           </a:xfrm>
           <a:prstGeom prst="rect">
             <a:avLst/>
@@ -7371,6 +7693,10 @@
                 <a:solidFill>
                   <a:srgbClr val="1B2A33"/>
                 </a:solidFill>
+                <a:latin typeface="+mj-lt"/>
+                <a:ea typeface="+mj-ea"/>
+                <a:cs typeface="+mj-cs"/>
+                <a:sym typeface="Calibri"/>
               </a:defRPr>
             </a:lvl1pPr>
           </a:lstStyle>
@@ -7390,8 +7716,8 @@
         </p:nvSpPr>
         <p:spPr>
           <a:xfrm>
-            <a:off x="6400799" y="5234940"/>
-            <a:ext cx="5120642" cy="457201"/>
+            <a:off x="6400798" y="5234940"/>
+            <a:ext cx="5120643" cy="457201"/>
           </a:xfrm>
           <a:prstGeom prst="rect">
             <a:avLst/>
@@ -7438,8 +7764,8 @@
         </p:nvSpPr>
         <p:spPr>
           <a:xfrm>
-            <a:off x="6400799" y="5897879"/>
-            <a:ext cx="5120642" cy="347366"/>
+            <a:off x="6400798" y="5897879"/>
+            <a:ext cx="5120643" cy="347365"/>
           </a:xfrm>
           <a:prstGeom prst="rect">
             <a:avLst/>
@@ -7463,6 +7789,10 @@
                 <a:solidFill>
                   <a:srgbClr val="1B2A33"/>
                 </a:solidFill>
+                <a:latin typeface="+mj-lt"/>
+                <a:ea typeface="+mj-ea"/>
+                <a:cs typeface="+mj-cs"/>
+                <a:sym typeface="Calibri"/>
               </a:defRPr>
             </a:lvl1pPr>
           </a:lstStyle>
@@ -7482,8 +7812,8 @@
         </p:nvSpPr>
         <p:spPr>
           <a:xfrm>
-            <a:off x="548640" y="6584188"/>
-            <a:ext cx="3657601" cy="127001"/>
+            <a:off x="548639" y="6584188"/>
+            <a:ext cx="3657603" cy="127001"/>
           </a:xfrm>
           <a:prstGeom prst="rect">
             <a:avLst/>
@@ -7507,6 +7837,10 @@
                 <a:solidFill>
                   <a:srgbClr val="5E7183"/>
                 </a:solidFill>
+                <a:latin typeface="+mj-lt"/>
+                <a:ea typeface="+mj-ea"/>
+                <a:cs typeface="+mj-cs"/>
+                <a:sym typeface="Calibri"/>
               </a:defRPr>
             </a:lvl1pPr>
           </a:lstStyle>
@@ -7527,7 +7861,7 @@
         <p:spPr>
           <a:xfrm>
             <a:off x="11277295" y="6584188"/>
-            <a:ext cx="365761" cy="127001"/>
+            <a:ext cx="365762" cy="127001"/>
           </a:xfrm>
           <a:prstGeom prst="rect">
             <a:avLst/>
@@ -7551,6 +7885,10 @@
                 <a:solidFill>
                   <a:srgbClr val="5E7183"/>
                 </a:solidFill>
+                <a:latin typeface="+mj-lt"/>
+                <a:ea typeface="+mj-ea"/>
+                <a:cs typeface="+mj-cs"/>
+                <a:sym typeface="Calibri"/>
               </a:defRPr>
             </a:lvl1pPr>
           </a:lstStyle>
@@ -7596,8 +7934,8 @@
         </p:nvSpPr>
         <p:spPr>
           <a:xfrm>
-            <a:off x="548639" y="362634"/>
-            <a:ext cx="11064242" cy="134268"/>
+            <a:off x="548638" y="362633"/>
+            <a:ext cx="11064244" cy="134269"/>
           </a:xfrm>
           <a:prstGeom prst="rect">
             <a:avLst/>
@@ -7621,6 +7959,10 @@
                 <a:solidFill>
                   <a:srgbClr val="1C7293"/>
                 </a:solidFill>
+                <a:latin typeface="+mj-lt"/>
+                <a:ea typeface="+mj-ea"/>
+                <a:cs typeface="+mj-cs"/>
+                <a:sym typeface="Calibri"/>
               </a:defRPr>
             </a:lvl1pPr>
           </a:lstStyle>
@@ -7640,8 +7982,8 @@
         </p:nvSpPr>
         <p:spPr>
           <a:xfrm>
-            <a:off x="548639" y="681227"/>
-            <a:ext cx="11064242" cy="457201"/>
+            <a:off x="548638" y="681227"/>
+            <a:ext cx="11064244" cy="457201"/>
           </a:xfrm>
           <a:prstGeom prst="rect">
             <a:avLst/>
@@ -7688,8 +8030,8 @@
         </p:nvSpPr>
         <p:spPr>
           <a:xfrm>
-            <a:off x="548639" y="1554479"/>
-            <a:ext cx="5760722" cy="2094360"/>
+            <a:off x="548638" y="1554478"/>
+            <a:ext cx="5760723" cy="2094360"/>
           </a:xfrm>
           <a:prstGeom prst="rect">
             <a:avLst/>
@@ -7719,6 +8061,10 @@
                 <a:solidFill>
                   <a:srgbClr val="1B2A33"/>
                 </a:solidFill>
+                <a:latin typeface="+mj-lt"/>
+                <a:ea typeface="+mj-ea"/>
+                <a:cs typeface="+mj-cs"/>
+                <a:sym typeface="Calibri"/>
               </a:defRPr>
             </a:pPr>
             <a:r>
@@ -7736,6 +8082,10 @@
                 <a:solidFill>
                   <a:srgbClr val="1B2A33"/>
                 </a:solidFill>
+                <a:latin typeface="+mj-lt"/>
+                <a:ea typeface="+mj-ea"/>
+                <a:cs typeface="+mj-cs"/>
+                <a:sym typeface="Calibri"/>
               </a:defRPr>
             </a:pPr>
             <a:r>
@@ -7753,6 +8103,10 @@
                 <a:solidFill>
                   <a:srgbClr val="1B2A33"/>
                 </a:solidFill>
+                <a:latin typeface="+mj-lt"/>
+                <a:ea typeface="+mj-ea"/>
+                <a:cs typeface="+mj-cs"/>
+                <a:sym typeface="Calibri"/>
               </a:defRPr>
             </a:pPr>
             <a:r>
@@ -7770,6 +8124,10 @@
                 <a:solidFill>
                   <a:srgbClr val="1B2A33"/>
                 </a:solidFill>
+                <a:latin typeface="+mj-lt"/>
+                <a:ea typeface="+mj-ea"/>
+                <a:cs typeface="+mj-cs"/>
+                <a:sym typeface="Calibri"/>
               </a:defRPr>
             </a:pPr>
             <a:r>
@@ -7786,7 +8144,7 @@
         </p:nvGraphicFramePr>
         <p:xfrm>
           <a:off x="548640" y="4572000"/>
-          <a:ext cx="4754881" cy="1243584"/>
+          <a:ext cx="4754882" cy="1243584"/>
         </p:xfrm>
         <a:graphic xmlns:a="http://schemas.openxmlformats.org/drawingml/2006/main">
           <a:graphicData uri="http://schemas.openxmlformats.org/drawingml/2006/table">
@@ -8500,8 +8858,8 @@
         </p:nvSpPr>
         <p:spPr>
           <a:xfrm>
-            <a:off x="6949440" y="1795780"/>
-            <a:ext cx="4572001" cy="660401"/>
+            <a:off x="6949440" y="1795779"/>
+            <a:ext cx="4572002" cy="660401"/>
           </a:xfrm>
           <a:prstGeom prst="rect">
             <a:avLst/>
@@ -8549,7 +8907,7 @@
         <p:spPr>
           <a:xfrm>
             <a:off x="6949440" y="2560320"/>
-            <a:ext cx="4572001" cy="156865"/>
+            <a:ext cx="4572002" cy="156865"/>
           </a:xfrm>
           <a:prstGeom prst="rect">
             <a:avLst/>
@@ -8573,6 +8931,10 @@
                 <a:solidFill>
                   <a:srgbClr val="1B2A33"/>
                 </a:solidFill>
+                <a:latin typeface="+mj-lt"/>
+                <a:ea typeface="+mj-ea"/>
+                <a:cs typeface="+mj-cs"/>
+                <a:sym typeface="Calibri"/>
               </a:defRPr>
             </a:lvl1pPr>
           </a:lstStyle>
@@ -8593,7 +8955,7 @@
         <p:spPr>
           <a:xfrm>
             <a:off x="6949440" y="3853179"/>
-            <a:ext cx="4572001" cy="660401"/>
+            <a:ext cx="4572002" cy="660401"/>
           </a:xfrm>
           <a:prstGeom prst="rect">
             <a:avLst/>
@@ -8641,7 +9003,7 @@
         <p:spPr>
           <a:xfrm>
             <a:off x="6949440" y="4617720"/>
-            <a:ext cx="4572001" cy="156865"/>
+            <a:ext cx="4572002" cy="156865"/>
           </a:xfrm>
           <a:prstGeom prst="rect">
             <a:avLst/>
@@ -8665,6 +9027,10 @@
                 <a:solidFill>
                   <a:srgbClr val="1B2A33"/>
                 </a:solidFill>
+                <a:latin typeface="+mj-lt"/>
+                <a:ea typeface="+mj-ea"/>
+                <a:cs typeface="+mj-cs"/>
+                <a:sym typeface="Calibri"/>
               </a:defRPr>
             </a:lvl1pPr>
           </a:lstStyle>
@@ -8684,8 +9050,8 @@
         </p:nvSpPr>
         <p:spPr>
           <a:xfrm>
-            <a:off x="548640" y="6584188"/>
-            <a:ext cx="3657601" cy="127001"/>
+            <a:off x="548639" y="6584188"/>
+            <a:ext cx="3657603" cy="127001"/>
           </a:xfrm>
           <a:prstGeom prst="rect">
             <a:avLst/>
@@ -8709,6 +9075,10 @@
                 <a:solidFill>
                   <a:srgbClr val="5E7183"/>
                 </a:solidFill>
+                <a:latin typeface="+mj-lt"/>
+                <a:ea typeface="+mj-ea"/>
+                <a:cs typeface="+mj-cs"/>
+                <a:sym typeface="Calibri"/>
               </a:defRPr>
             </a:lvl1pPr>
           </a:lstStyle>
@@ -8729,7 +9099,7 @@
         <p:spPr>
           <a:xfrm>
             <a:off x="11277295" y="6584188"/>
-            <a:ext cx="365761" cy="127001"/>
+            <a:ext cx="365762" cy="127001"/>
           </a:xfrm>
           <a:prstGeom prst="rect">
             <a:avLst/>
@@ -8753,6 +9123,10 @@
                 <a:solidFill>
                   <a:srgbClr val="5E7183"/>
                 </a:solidFill>
+                <a:latin typeface="+mj-lt"/>
+                <a:ea typeface="+mj-ea"/>
+                <a:cs typeface="+mj-cs"/>
+                <a:sym typeface="Calibri"/>
               </a:defRPr>
             </a:lvl1pPr>
           </a:lstStyle>
@@ -8798,8 +9172,8 @@
         </p:nvSpPr>
         <p:spPr>
           <a:xfrm>
-            <a:off x="548639" y="362634"/>
-            <a:ext cx="11064242" cy="134268"/>
+            <a:off x="548638" y="362633"/>
+            <a:ext cx="11064244" cy="134269"/>
           </a:xfrm>
           <a:prstGeom prst="rect">
             <a:avLst/>
@@ -8823,6 +9197,10 @@
                 <a:solidFill>
                   <a:srgbClr val="1C7293"/>
                 </a:solidFill>
+                <a:latin typeface="+mj-lt"/>
+                <a:ea typeface="+mj-ea"/>
+                <a:cs typeface="+mj-cs"/>
+                <a:sym typeface="Calibri"/>
               </a:defRPr>
             </a:lvl1pPr>
           </a:lstStyle>
@@ -8842,8 +9220,8 @@
         </p:nvSpPr>
         <p:spPr>
           <a:xfrm>
-            <a:off x="548639" y="681227"/>
-            <a:ext cx="11064242" cy="457201"/>
+            <a:off x="548638" y="681227"/>
+            <a:ext cx="11064244" cy="457201"/>
           </a:xfrm>
           <a:prstGeom prst="rect">
             <a:avLst/>
@@ -8900,8 +9278,8 @@
         </p:blipFill>
         <p:spPr>
           <a:xfrm>
-            <a:off x="1981048" y="1463039"/>
-            <a:ext cx="8229601" cy="2743201"/>
+            <a:off x="1981048" y="1463038"/>
+            <a:ext cx="8229601" cy="2743202"/>
           </a:xfrm>
           <a:prstGeom prst="rect">
             <a:avLst/>
@@ -8919,8 +9297,8 @@
         </p:nvSpPr>
         <p:spPr>
           <a:xfrm>
-            <a:off x="548639" y="4366304"/>
-            <a:ext cx="11064242" cy="137072"/>
+            <a:off x="548638" y="4366304"/>
+            <a:ext cx="11064244" cy="137071"/>
           </a:xfrm>
           <a:prstGeom prst="rect">
             <a:avLst/>
@@ -8944,6 +9322,10 @@
                 <a:solidFill>
                   <a:srgbClr val="5E7183"/>
                 </a:solidFill>
+                <a:latin typeface="+mj-lt"/>
+                <a:ea typeface="+mj-ea"/>
+                <a:cs typeface="+mj-cs"/>
+                <a:sym typeface="Calibri"/>
               </a:defRPr>
             </a:lvl1pPr>
           </a:lstStyle>
@@ -8964,7 +9346,7 @@
         <p:spPr>
           <a:xfrm>
             <a:off x="548640" y="4709159"/>
-            <a:ext cx="3538729" cy="1600201"/>
+            <a:ext cx="3538729" cy="1600202"/>
           </a:xfrm>
           <a:prstGeom prst="roundRect">
             <a:avLst>
@@ -8981,10 +9363,17 @@
           </a:ln>
         </p:spPr>
         <p:txBody>
-          <a:bodyPr lIns="45719" rIns="45719"/>
+          <a:bodyPr lIns="45718" tIns="45718" rIns="45718" bIns="45718"/>
           <a:lstStyle/>
           <a:p>
-            <a:pPr/>
+            <a:pPr>
+              <a:defRPr>
+                <a:latin typeface="+mj-lt"/>
+                <a:ea typeface="+mj-ea"/>
+                <a:cs typeface="+mj-cs"/>
+                <a:sym typeface="Calibri"/>
+              </a:defRPr>
+            </a:pPr>
           </a:p>
         </p:txBody>
       </p:sp>
@@ -8996,8 +9385,8 @@
         </p:nvSpPr>
         <p:spPr>
           <a:xfrm>
-            <a:off x="749807" y="4855464"/>
-            <a:ext cx="3136394" cy="677565"/>
+            <a:off x="749806" y="4855464"/>
+            <a:ext cx="3136396" cy="677565"/>
           </a:xfrm>
           <a:prstGeom prst="rect">
             <a:avLst/>
@@ -9025,6 +9414,10 @@
                 <a:solidFill>
                   <a:srgbClr val="065A82"/>
                 </a:solidFill>
+                <a:latin typeface="+mj-lt"/>
+                <a:ea typeface="+mj-ea"/>
+                <a:cs typeface="+mj-cs"/>
+                <a:sym typeface="Calibri"/>
               </a:defRPr>
             </a:pPr>
             <a:r>
@@ -9040,6 +9433,10 @@
                 <a:solidFill>
                   <a:srgbClr val="1B2A33"/>
                 </a:solidFill>
+                <a:latin typeface="+mj-lt"/>
+                <a:ea typeface="+mj-ea"/>
+                <a:cs typeface="+mj-cs"/>
+                <a:sym typeface="Calibri"/>
               </a:defRPr>
             </a:pPr>
             <a:r>
@@ -9057,7 +9454,7 @@
         <p:spPr>
           <a:xfrm>
             <a:off x="4315967" y="4709159"/>
-            <a:ext cx="3538730" cy="1600201"/>
+            <a:ext cx="3538731" cy="1600202"/>
           </a:xfrm>
           <a:prstGeom prst="roundRect">
             <a:avLst>
@@ -9074,10 +9471,17 @@
           </a:ln>
         </p:spPr>
         <p:txBody>
-          <a:bodyPr lIns="45719" rIns="45719"/>
+          <a:bodyPr lIns="45718" tIns="45718" rIns="45718" bIns="45718"/>
           <a:lstStyle/>
           <a:p>
-            <a:pPr/>
+            <a:pPr>
+              <a:defRPr>
+                <a:latin typeface="+mj-lt"/>
+                <a:ea typeface="+mj-ea"/>
+                <a:cs typeface="+mj-cs"/>
+                <a:sym typeface="Calibri"/>
+              </a:defRPr>
+            </a:pPr>
           </a:p>
         </p:txBody>
       </p:sp>
@@ -9090,7 +9494,7 @@
         <p:spPr>
           <a:xfrm>
             <a:off x="4517135" y="4855464"/>
-            <a:ext cx="3136393" cy="677565"/>
+            <a:ext cx="3136394" cy="677565"/>
           </a:xfrm>
           <a:prstGeom prst="rect">
             <a:avLst/>
@@ -9118,6 +9522,10 @@
                 <a:solidFill>
                   <a:srgbClr val="065A82"/>
                 </a:solidFill>
+                <a:latin typeface="+mj-lt"/>
+                <a:ea typeface="+mj-ea"/>
+                <a:cs typeface="+mj-cs"/>
+                <a:sym typeface="Calibri"/>
               </a:defRPr>
             </a:pPr>
             <a:r>
@@ -9133,6 +9541,10 @@
                 <a:solidFill>
                   <a:srgbClr val="1B2A33"/>
                 </a:solidFill>
+                <a:latin typeface="+mj-lt"/>
+                <a:ea typeface="+mj-ea"/>
+                <a:cs typeface="+mj-cs"/>
+                <a:sym typeface="Calibri"/>
               </a:defRPr>
             </a:pPr>
             <a:r>
@@ -9149,8 +9561,8 @@
         </p:nvSpPr>
         <p:spPr>
           <a:xfrm>
-            <a:off x="8083295" y="4709159"/>
-            <a:ext cx="3538729" cy="1600201"/>
+            <a:off x="8083294" y="4709159"/>
+            <a:ext cx="3538730" cy="1600202"/>
           </a:xfrm>
           <a:prstGeom prst="roundRect">
             <a:avLst>
@@ -9167,10 +9579,17 @@
           </a:ln>
         </p:spPr>
         <p:txBody>
-          <a:bodyPr lIns="45719" rIns="45719"/>
+          <a:bodyPr lIns="45718" tIns="45718" rIns="45718" bIns="45718"/>
           <a:lstStyle/>
           <a:p>
-            <a:pPr/>
+            <a:pPr>
+              <a:defRPr>
+                <a:latin typeface="+mj-lt"/>
+                <a:ea typeface="+mj-ea"/>
+                <a:cs typeface="+mj-cs"/>
+                <a:sym typeface="Calibri"/>
+              </a:defRPr>
+            </a:pPr>
           </a:p>
         </p:txBody>
       </p:sp>
@@ -9183,7 +9602,7 @@
         <p:spPr>
           <a:xfrm>
             <a:off x="8284464" y="4855464"/>
-            <a:ext cx="3136393" cy="868065"/>
+            <a:ext cx="3136394" cy="868065"/>
           </a:xfrm>
           <a:prstGeom prst="rect">
             <a:avLst/>
@@ -9211,6 +9630,10 @@
                 <a:solidFill>
                   <a:srgbClr val="065A82"/>
                 </a:solidFill>
+                <a:latin typeface="+mj-lt"/>
+                <a:ea typeface="+mj-ea"/>
+                <a:cs typeface="+mj-cs"/>
+                <a:sym typeface="Calibri"/>
               </a:defRPr>
             </a:pPr>
             <a:r>
@@ -9226,6 +9649,10 @@
                 <a:solidFill>
                   <a:srgbClr val="1B2A33"/>
                 </a:solidFill>
+                <a:latin typeface="+mj-lt"/>
+                <a:ea typeface="+mj-ea"/>
+                <a:cs typeface="+mj-cs"/>
+                <a:sym typeface="Calibri"/>
               </a:defRPr>
             </a:pPr>
             <a:r>
@@ -9242,8 +9669,8 @@
         </p:nvSpPr>
         <p:spPr>
           <a:xfrm>
-            <a:off x="548640" y="6584188"/>
-            <a:ext cx="3657601" cy="127001"/>
+            <a:off x="548639" y="6584188"/>
+            <a:ext cx="3657603" cy="127001"/>
           </a:xfrm>
           <a:prstGeom prst="rect">
             <a:avLst/>
@@ -9267,6 +9694,10 @@
                 <a:solidFill>
                   <a:srgbClr val="5E7183"/>
                 </a:solidFill>
+                <a:latin typeface="+mj-lt"/>
+                <a:ea typeface="+mj-ea"/>
+                <a:cs typeface="+mj-cs"/>
+                <a:sym typeface="Calibri"/>
               </a:defRPr>
             </a:lvl1pPr>
           </a:lstStyle>
@@ -9287,7 +9718,7 @@
         <p:spPr>
           <a:xfrm>
             <a:off x="11277295" y="6584188"/>
-            <a:ext cx="365761" cy="127001"/>
+            <a:ext cx="365762" cy="127001"/>
           </a:xfrm>
           <a:prstGeom prst="rect">
             <a:avLst/>
@@ -9311,6 +9742,10 @@
                 <a:solidFill>
                   <a:srgbClr val="5E7183"/>
                 </a:solidFill>
+                <a:latin typeface="+mj-lt"/>
+                <a:ea typeface="+mj-ea"/>
+                <a:cs typeface="+mj-cs"/>
+                <a:sym typeface="Calibri"/>
               </a:defRPr>
             </a:lvl1pPr>
           </a:lstStyle>
@@ -9356,8 +9791,8 @@
         </p:nvSpPr>
         <p:spPr>
           <a:xfrm>
-            <a:off x="548639" y="362634"/>
-            <a:ext cx="11064242" cy="134268"/>
+            <a:off x="548638" y="362633"/>
+            <a:ext cx="11064244" cy="134269"/>
           </a:xfrm>
           <a:prstGeom prst="rect">
             <a:avLst/>
@@ -9381,6 +9816,10 @@
                 <a:solidFill>
                   <a:srgbClr val="1C7293"/>
                 </a:solidFill>
+                <a:latin typeface="+mj-lt"/>
+                <a:ea typeface="+mj-ea"/>
+                <a:cs typeface="+mj-cs"/>
+                <a:sym typeface="Calibri"/>
               </a:defRPr>
             </a:lvl1pPr>
           </a:lstStyle>
@@ -9400,8 +9839,8 @@
         </p:nvSpPr>
         <p:spPr>
           <a:xfrm>
-            <a:off x="548639" y="681227"/>
-            <a:ext cx="11064242" cy="457201"/>
+            <a:off x="548638" y="681227"/>
+            <a:ext cx="11064244" cy="457201"/>
           </a:xfrm>
           <a:prstGeom prst="rect">
             <a:avLst/>
@@ -9459,7 +9898,7 @@
         <p:spPr>
           <a:xfrm>
             <a:off x="6537959" y="1600200"/>
-            <a:ext cx="5074921" cy="3137224"/>
+            <a:ext cx="5074921" cy="3137225"/>
           </a:xfrm>
           <a:prstGeom prst="rect">
             <a:avLst/>
@@ -9477,8 +9916,8 @@
         </p:nvSpPr>
         <p:spPr>
           <a:xfrm>
-            <a:off x="6537959" y="4892084"/>
-            <a:ext cx="5074921" cy="137072"/>
+            <a:off x="6537958" y="4892083"/>
+            <a:ext cx="5074923" cy="137072"/>
           </a:xfrm>
           <a:prstGeom prst="rect">
             <a:avLst/>
@@ -9502,6 +9941,10 @@
                 <a:solidFill>
                   <a:srgbClr val="5E7183"/>
                 </a:solidFill>
+                <a:latin typeface="+mj-lt"/>
+                <a:ea typeface="+mj-ea"/>
+                <a:cs typeface="+mj-cs"/>
+                <a:sym typeface="Calibri"/>
               </a:defRPr>
             </a:lvl1pPr>
           </a:lstStyle>
@@ -9522,7 +9965,7 @@
         <p:spPr>
           <a:xfrm>
             <a:off x="548640" y="1666941"/>
-            <a:ext cx="5669280" cy="186558"/>
+            <a:ext cx="5669280" cy="186557"/>
           </a:xfrm>
           <a:prstGeom prst="rect">
             <a:avLst/>
@@ -9546,6 +9989,10 @@
                 <a:solidFill>
                   <a:srgbClr val="065A82"/>
                 </a:solidFill>
+                <a:latin typeface="+mj-lt"/>
+                <a:ea typeface="+mj-ea"/>
+                <a:cs typeface="+mj-cs"/>
+                <a:sym typeface="Calibri"/>
               </a:defRPr>
             </a:lvl1pPr>
           </a:lstStyle>
@@ -9565,7 +10012,7 @@
         </p:nvSpPr>
         <p:spPr>
           <a:xfrm>
-            <a:off x="685800" y="2011679"/>
+            <a:off x="685800" y="2011678"/>
             <a:ext cx="5669280" cy="750963"/>
           </a:xfrm>
           <a:prstGeom prst="rect">
@@ -9596,6 +10043,10 @@
                 <a:solidFill>
                   <a:srgbClr val="1B2A33"/>
                 </a:solidFill>
+                <a:latin typeface="+mj-lt"/>
+                <a:ea typeface="+mj-ea"/>
+                <a:cs typeface="+mj-cs"/>
+                <a:sym typeface="Calibri"/>
               </a:defRPr>
             </a:pPr>
             <a:r>
@@ -9613,6 +10064,10 @@
                 <a:solidFill>
                   <a:srgbClr val="1B2A33"/>
                 </a:solidFill>
+                <a:latin typeface="+mj-lt"/>
+                <a:ea typeface="+mj-ea"/>
+                <a:cs typeface="+mj-cs"/>
+                <a:sym typeface="Calibri"/>
               </a:defRPr>
             </a:pPr>
             <a:r>
@@ -9630,6 +10085,10 @@
                 <a:solidFill>
                   <a:srgbClr val="1B2A33"/>
                 </a:solidFill>
+                <a:latin typeface="+mj-lt"/>
+                <a:ea typeface="+mj-ea"/>
+                <a:cs typeface="+mj-cs"/>
+                <a:sym typeface="Calibri"/>
               </a:defRPr>
             </a:pPr>
             <a:r>
@@ -9672,6 +10131,10 @@
                 <a:solidFill>
                   <a:srgbClr val="2E9E5B"/>
                 </a:solidFill>
+                <a:latin typeface="+mj-lt"/>
+                <a:ea typeface="+mj-ea"/>
+                <a:cs typeface="+mj-cs"/>
+                <a:sym typeface="Calibri"/>
               </a:defRPr>
             </a:pPr>
             <a:r>
@@ -9687,6 +10150,10 @@
                 <a:solidFill>
                   <a:srgbClr val="1B2A33"/>
                 </a:solidFill>
+                <a:latin typeface="+mj-lt"/>
+                <a:ea typeface="+mj-ea"/>
+                <a:cs typeface="+mj-cs"/>
+                <a:sym typeface="Calibri"/>
               </a:defRPr>
             </a:pPr>
             <a:r>
@@ -9699,6 +10166,10 @@
                 <a:solidFill>
                   <a:srgbClr val="C4452F"/>
                 </a:solidFill>
+                <a:latin typeface="+mj-lt"/>
+                <a:ea typeface="+mj-ea"/>
+                <a:cs typeface="+mj-cs"/>
+                <a:sym typeface="Calibri"/>
               </a:defRPr>
             </a:pPr>
             <a:r>
@@ -9714,6 +10185,10 @@
                 <a:solidFill>
                   <a:srgbClr val="1B2A33"/>
                 </a:solidFill>
+                <a:latin typeface="+mj-lt"/>
+                <a:ea typeface="+mj-ea"/>
+                <a:cs typeface="+mj-cs"/>
+                <a:sym typeface="Calibri"/>
               </a:defRPr>
             </a:pPr>
             <a:r>
@@ -9726,6 +10201,10 @@
                 <a:solidFill>
                   <a:srgbClr val="C4452F"/>
                 </a:solidFill>
+                <a:latin typeface="+mj-lt"/>
+                <a:ea typeface="+mj-ea"/>
+                <a:cs typeface="+mj-cs"/>
+                <a:sym typeface="Calibri"/>
               </a:defRPr>
             </a:pPr>
             <a:r>
@@ -9738,6 +10217,10 @@
                 <a:solidFill>
                   <a:srgbClr val="1B2A33"/>
                 </a:solidFill>
+                <a:latin typeface="+mj-lt"/>
+                <a:ea typeface="+mj-ea"/>
+                <a:cs typeface="+mj-cs"/>
+                <a:sym typeface="Calibri"/>
               </a:defRPr>
             </a:pPr>
             <a:r>
@@ -9754,8 +10237,8 @@
         </p:nvSpPr>
         <p:spPr>
           <a:xfrm>
-            <a:off x="548640" y="6584188"/>
-            <a:ext cx="3657601" cy="127001"/>
+            <a:off x="548639" y="6584188"/>
+            <a:ext cx="3657603" cy="127001"/>
           </a:xfrm>
           <a:prstGeom prst="rect">
             <a:avLst/>
@@ -9779,6 +10262,10 @@
                 <a:solidFill>
                   <a:srgbClr val="5E7183"/>
                 </a:solidFill>
+                <a:latin typeface="+mj-lt"/>
+                <a:ea typeface="+mj-ea"/>
+                <a:cs typeface="+mj-cs"/>
+                <a:sym typeface="Calibri"/>
               </a:defRPr>
             </a:lvl1pPr>
           </a:lstStyle>
@@ -9799,7 +10286,7 @@
         <p:spPr>
           <a:xfrm>
             <a:off x="11277295" y="6584188"/>
-            <a:ext cx="365761" cy="127001"/>
+            <a:ext cx="365762" cy="127001"/>
           </a:xfrm>
           <a:prstGeom prst="rect">
             <a:avLst/>
@@ -9823,6 +10310,10 @@
                 <a:solidFill>
                   <a:srgbClr val="5E7183"/>
                 </a:solidFill>
+                <a:latin typeface="+mj-lt"/>
+                <a:ea typeface="+mj-ea"/>
+                <a:cs typeface="+mj-cs"/>
+                <a:sym typeface="Calibri"/>
               </a:defRPr>
             </a:lvl1pPr>
           </a:lstStyle>
@@ -10036,17 +10527,17 @@
         <a:solidFill>
           <a:srgbClr val="FFFFFF"/>
         </a:solidFill>
-        <a:ln w="12700" cap="flat">
+        <a:ln w="25400" cap="flat">
           <a:solidFill>
             <a:schemeClr val="accent1"/>
           </a:solidFill>
           <a:prstDash val="solid"/>
-          <a:miter lim="800000"/>
+          <a:round/>
         </a:ln>
         <a:effectLst/>
         <a:sp3d/>
       </a:spPr>
-      <a:bodyPr rot="0" spcFirstLastPara="1" vertOverflow="overflow" horzOverflow="overflow" vert="horz" wrap="square" lIns="45719" tIns="45719" rIns="45719" bIns="45719" numCol="1" spcCol="38100" rtlCol="0" anchor="ctr" upright="0">
+      <a:bodyPr rot="0" spcFirstLastPara="1" vertOverflow="overflow" horzOverflow="overflow" vert="horz" wrap="square" lIns="45718" tIns="45718" rIns="45718" bIns="45718" numCol="1" spcCol="38100" rtlCol="0" anchor="ctr" upright="0">
         <a:spAutoFit/>
       </a:bodyPr>
       <a:lstStyle>
@@ -10074,10 +10565,10 @@
             </a:solidFill>
             <a:effectLst/>
             <a:uFillTx/>
-            <a:latin typeface="+mj-lt"/>
-            <a:ea typeface="+mj-ea"/>
-            <a:cs typeface="+mj-cs"/>
-            <a:sym typeface="Calibri"/>
+            <a:latin typeface="+mn-lt"/>
+            <a:ea typeface="+mn-ea"/>
+            <a:cs typeface="+mn-cs"/>
+            <a:sym typeface="Helvetica"/>
           </a:defRPr>
         </a:defPPr>
         <a:lvl1pPr marL="0" marR="0" indent="0" algn="l" defTabSz="914400" rtl="0" fontAlgn="auto" latinLnBrk="1" hangingPunct="0">
@@ -10325,12 +10816,12 @@
     <a:lnDef>
       <a:spPr>
         <a:noFill/>
-        <a:ln w="12700" cap="flat">
+        <a:ln w="25400" cap="flat">
           <a:solidFill>
             <a:schemeClr val="accent1"/>
           </a:solidFill>
           <a:prstDash val="solid"/>
-          <a:miter lim="800000"/>
+          <a:round/>
         </a:ln>
         <a:effectLst/>
         <a:sp3d/>
@@ -10617,7 +11108,7 @@
         <a:effectLst/>
         <a:sp3d/>
       </a:spPr>
-      <a:bodyPr rot="0" spcFirstLastPara="1" vertOverflow="overflow" horzOverflow="overflow" vert="horz" wrap="square" lIns="45719" tIns="45719" rIns="45719" bIns="45719" numCol="1" spcCol="38100" rtlCol="0" anchor="t" upright="0">
+      <a:bodyPr rot="0" spcFirstLastPara="1" vertOverflow="overflow" horzOverflow="overflow" vert="horz" wrap="square" lIns="45718" tIns="45718" rIns="45718" bIns="45718" numCol="1" spcCol="38100" rtlCol="0" anchor="t" upright="0">
         <a:spAutoFit/>
       </a:bodyPr>
       <a:lstStyle>
@@ -10645,10 +11136,10 @@
             </a:solidFill>
             <a:effectLst/>
             <a:uFillTx/>
-            <a:latin typeface="+mj-lt"/>
-            <a:ea typeface="+mj-ea"/>
-            <a:cs typeface="+mj-cs"/>
-            <a:sym typeface="Calibri"/>
+            <a:latin typeface="+mn-lt"/>
+            <a:ea typeface="+mn-ea"/>
+            <a:cs typeface="+mn-cs"/>
+            <a:sym typeface="Helvetica"/>
           </a:defRPr>
         </a:defPPr>
         <a:lvl1pPr marL="0" marR="0" indent="0" algn="l" defTabSz="914400" rtl="0" fontAlgn="auto" latinLnBrk="1" hangingPunct="0">
@@ -11090,17 +11581,17 @@
         <a:solidFill>
           <a:srgbClr val="FFFFFF"/>
         </a:solidFill>
-        <a:ln w="12700" cap="flat">
+        <a:ln w="25400" cap="flat">
           <a:solidFill>
             <a:schemeClr val="accent1"/>
           </a:solidFill>
           <a:prstDash val="solid"/>
-          <a:miter lim="800000"/>
+          <a:round/>
         </a:ln>
         <a:effectLst/>
         <a:sp3d/>
       </a:spPr>
-      <a:bodyPr rot="0" spcFirstLastPara="1" vertOverflow="overflow" horzOverflow="overflow" vert="horz" wrap="square" lIns="45719" tIns="45719" rIns="45719" bIns="45719" numCol="1" spcCol="38100" rtlCol="0" anchor="ctr" upright="0">
+      <a:bodyPr rot="0" spcFirstLastPara="1" vertOverflow="overflow" horzOverflow="overflow" vert="horz" wrap="square" lIns="45718" tIns="45718" rIns="45718" bIns="45718" numCol="1" spcCol="38100" rtlCol="0" anchor="ctr" upright="0">
         <a:spAutoFit/>
       </a:bodyPr>
       <a:lstStyle>
@@ -11128,10 +11619,10 @@
             </a:solidFill>
             <a:effectLst/>
             <a:uFillTx/>
-            <a:latin typeface="+mj-lt"/>
-            <a:ea typeface="+mj-ea"/>
-            <a:cs typeface="+mj-cs"/>
-            <a:sym typeface="Calibri"/>
+            <a:latin typeface="+mn-lt"/>
+            <a:ea typeface="+mn-ea"/>
+            <a:cs typeface="+mn-cs"/>
+            <a:sym typeface="Helvetica"/>
           </a:defRPr>
         </a:defPPr>
         <a:lvl1pPr marL="0" marR="0" indent="0" algn="l" defTabSz="914400" rtl="0" fontAlgn="auto" latinLnBrk="1" hangingPunct="0">
@@ -11379,12 +11870,12 @@
     <a:lnDef>
       <a:spPr>
         <a:noFill/>
-        <a:ln w="12700" cap="flat">
+        <a:ln w="25400" cap="flat">
           <a:solidFill>
             <a:schemeClr val="accent1"/>
           </a:solidFill>
           <a:prstDash val="solid"/>
-          <a:miter lim="800000"/>
+          <a:round/>
         </a:ln>
         <a:effectLst/>
         <a:sp3d/>
@@ -11671,7 +12162,7 @@
         <a:effectLst/>
         <a:sp3d/>
       </a:spPr>
-      <a:bodyPr rot="0" spcFirstLastPara="1" vertOverflow="overflow" horzOverflow="overflow" vert="horz" wrap="square" lIns="45719" tIns="45719" rIns="45719" bIns="45719" numCol="1" spcCol="38100" rtlCol="0" anchor="t" upright="0">
+      <a:bodyPr rot="0" spcFirstLastPara="1" vertOverflow="overflow" horzOverflow="overflow" vert="horz" wrap="square" lIns="45718" tIns="45718" rIns="45718" bIns="45718" numCol="1" spcCol="38100" rtlCol="0" anchor="t" upright="0">
         <a:spAutoFit/>
       </a:bodyPr>
       <a:lstStyle>
@@ -11699,10 +12190,10 @@
             </a:solidFill>
             <a:effectLst/>
             <a:uFillTx/>
-            <a:latin typeface="+mj-lt"/>
-            <a:ea typeface="+mj-ea"/>
-            <a:cs typeface="+mj-cs"/>
-            <a:sym typeface="Calibri"/>
+            <a:latin typeface="+mn-lt"/>
+            <a:ea typeface="+mn-ea"/>
+            <a:cs typeface="+mn-cs"/>
+            <a:sym typeface="Helvetica"/>
           </a:defRPr>
         </a:defPPr>
         <a:lvl1pPr marL="0" marR="0" indent="0" algn="l" defTabSz="914400" rtl="0" fontAlgn="auto" latinLnBrk="1" hangingPunct="0">

</xml_diff>